<commit_message>
Tighten compose spacing, title gaps, and nested text fit.
Nested panels now weight width, top-align, and autofit so side-by-side slides stay readable; rebuild example PPTXs to match.

Co-authored-by: Cursor <cursoragent@cursor.com>
</commit_message>
<xml_diff>
--- a/examples/apparel-markdown.pptx
+++ b/examples/apparel-markdown.pptx
@@ -1665,7 +1665,7 @@
         <p:spPr>
           <a:xfrm>
             <a:off x="400050" y="838200"/>
-            <a:ext cx="7239000" cy="914400"/>
+            <a:ext cx="7239000" cy="933450"/>
           </a:xfrm>
           <a:prstGeom prst="rect">
             <a:avLst/>
@@ -1726,8 +1726,8 @@
         </p:nvSpPr>
         <p:spPr>
           <a:xfrm>
-            <a:off x="400050" y="1924050"/>
-            <a:ext cx="6858000" cy="609600"/>
+            <a:off x="400050" y="2038350"/>
+            <a:ext cx="6858000" cy="457200"/>
           </a:xfrm>
           <a:prstGeom prst="rect">
             <a:avLst/>
@@ -1765,7 +1765,7 @@
         </p:nvSpPr>
         <p:spPr>
           <a:xfrm>
-            <a:off x="400050" y="2609850"/>
+            <a:off x="400050" y="2686050"/>
             <a:ext cx="1238250" cy="285750"/>
           </a:xfrm>
           <a:prstGeom prst="roundRect">
@@ -1792,7 +1792,7 @@
         </p:nvSpPr>
         <p:spPr>
           <a:xfrm>
-            <a:off x="476250" y="2667000"/>
+            <a:off x="476250" y="2743200"/>
             <a:ext cx="1085850" cy="171450"/>
           </a:xfrm>
           <a:prstGeom prst="rect">
@@ -1831,7 +1831,7 @@
         </p:nvSpPr>
         <p:spPr>
           <a:xfrm>
-            <a:off x="400050" y="3028950"/>
+            <a:off x="400050" y="3105150"/>
             <a:ext cx="6667500" cy="342900"/>
           </a:xfrm>
           <a:prstGeom prst="rect">
@@ -2400,8 +2400,8 @@
         </p:nvSpPr>
         <p:spPr>
           <a:xfrm>
-            <a:off x="1524000" y="2190750"/>
-            <a:ext cx="9144000" cy="1047750"/>
+            <a:off x="1524000" y="2552700"/>
+            <a:ext cx="9144000" cy="609600"/>
           </a:xfrm>
           <a:prstGeom prst="rect">
             <a:avLst/>
@@ -2439,8 +2439,8 @@
         </p:nvSpPr>
         <p:spPr>
           <a:xfrm>
-            <a:off x="1524000" y="3381375"/>
-            <a:ext cx="9144000" cy="428625"/>
+            <a:off x="1524000" y="3467100"/>
+            <a:ext cx="9144000" cy="457200"/>
           </a:xfrm>
           <a:prstGeom prst="rect">
             <a:avLst/>
@@ -2619,7 +2619,7 @@
         <p:spPr>
           <a:xfrm>
             <a:off x="400050" y="247650"/>
-            <a:ext cx="10839450" cy="381000"/>
+            <a:ext cx="10839450" cy="428625"/>
           </a:xfrm>
           <a:prstGeom prst="rect">
             <a:avLst/>
@@ -2635,7 +2635,7 @@
               <a:buNone/>
             </a:pPr>
             <a:r>
-              <a:rPr lang="en-US" sz="3000" b="1" dirty="0">
+              <a:rPr lang="en-US" sz="3200" b="1" dirty="0">
                 <a:solidFill>
                   <a:srgbClr val="EAEAEA"/>
                 </a:solidFill>
@@ -2645,7 +2645,7 @@
               </a:rPr>
               <a:t>Reactive markdown vs intentional markdown</a:t>
             </a:r>
-            <a:endParaRPr lang="en-US" sz="3000" dirty="0"/>
+            <a:endParaRPr lang="en-US" sz="3200" dirty="0"/>
           </a:p>
         </p:txBody>
       </p:sp>
@@ -2657,8 +2657,8 @@
         </p:nvSpPr>
         <p:spPr>
           <a:xfrm>
-            <a:off x="400050" y="800100"/>
-            <a:ext cx="10648950" cy="266700"/>
+            <a:off x="400050" y="942975"/>
+            <a:ext cx="10648950" cy="285750"/>
           </a:xfrm>
           <a:prstGeom prst="rect">
             <a:avLst/>
@@ -2774,12 +2774,12 @@
         </p:nvSpPr>
         <p:spPr>
           <a:xfrm>
-            <a:off x="400050" y="1219200"/>
-            <a:ext cx="5695950" cy="5105400"/>
+            <a:off x="400050" y="1457325"/>
+            <a:ext cx="5695950" cy="4867275"/>
           </a:xfrm>
           <a:prstGeom prst="roundRect">
             <a:avLst>
-              <a:gd name="adj" fmla="val 1791"/>
+              <a:gd name="adj" fmla="val 1879"/>
             </a:avLst>
           </a:prstGeom>
           <a:solidFill>
@@ -2801,7 +2801,7 @@
         </p:nvSpPr>
         <p:spPr>
           <a:xfrm>
-            <a:off x="400050" y="1219200"/>
+            <a:off x="400050" y="1457325"/>
             <a:ext cx="5695950" cy="76200"/>
           </a:xfrm>
           <a:prstGeom prst="rect">
@@ -2826,7 +2826,7 @@
         </p:nvSpPr>
         <p:spPr>
           <a:xfrm>
-            <a:off x="609600" y="1447800"/>
+            <a:off x="609600" y="1685925"/>
             <a:ext cx="5276850" cy="171450"/>
           </a:xfrm>
           <a:prstGeom prst="rect">
@@ -2865,7 +2865,7 @@
         </p:nvSpPr>
         <p:spPr>
           <a:xfrm>
-            <a:off x="609600" y="1743075"/>
+            <a:off x="609600" y="1981200"/>
             <a:ext cx="5276850" cy="476250"/>
           </a:xfrm>
           <a:prstGeom prst="rect">
@@ -2904,7 +2904,7 @@
         </p:nvSpPr>
         <p:spPr>
           <a:xfrm>
-            <a:off x="609600" y="2505075"/>
+            <a:off x="609600" y="2828925"/>
             <a:ext cx="66675" cy="66675"/>
           </a:xfrm>
           <a:prstGeom prst="roundRect">
@@ -2931,17 +2931,17 @@
         </p:nvSpPr>
         <p:spPr>
           <a:xfrm>
-            <a:off x="800100" y="2419350"/>
-            <a:ext cx="5086350" cy="342900"/>
-          </a:xfrm>
-          <a:prstGeom prst="rect">
-            <a:avLst/>
-          </a:prstGeom>
-          <a:noFill/>
-          <a:ln/>
-        </p:spPr>
-        <p:txBody>
-          <a:bodyPr wrap="square" lIns="0" tIns="0" rIns="0" bIns="0" rtlCol="0" anchor="t"/>
+            <a:off x="800100" y="2657475"/>
+            <a:ext cx="5086350" cy="419100"/>
+          </a:xfrm>
+          <a:prstGeom prst="rect">
+            <a:avLst/>
+          </a:prstGeom>
+          <a:noFill/>
+          <a:ln/>
+        </p:spPr>
+        <p:txBody>
+          <a:bodyPr wrap="square" lIns="0" tIns="0" rIns="0" bIns="0" rtlCol="0" anchor="ctr"/>
           <a:lstStyle/>
           <a:p>
             <a:pPr algn="l" indent="0" marL="0">
@@ -2970,7 +2970,7 @@
         </p:nvSpPr>
         <p:spPr>
           <a:xfrm>
-            <a:off x="609600" y="3038475"/>
+            <a:off x="609600" y="3286125"/>
             <a:ext cx="66675" cy="66675"/>
           </a:xfrm>
           <a:prstGeom prst="roundRect">
@@ -2997,17 +2997,17 @@
         </p:nvSpPr>
         <p:spPr>
           <a:xfrm>
-            <a:off x="800100" y="2952750"/>
-            <a:ext cx="5086350" cy="342900"/>
-          </a:xfrm>
-          <a:prstGeom prst="rect">
-            <a:avLst/>
-          </a:prstGeom>
-          <a:noFill/>
-          <a:ln/>
-        </p:spPr>
-        <p:txBody>
-          <a:bodyPr wrap="square" lIns="0" tIns="0" rIns="0" bIns="0" rtlCol="0" anchor="t"/>
+            <a:off x="800100" y="3114675"/>
+            <a:ext cx="5086350" cy="419100"/>
+          </a:xfrm>
+          <a:prstGeom prst="rect">
+            <a:avLst/>
+          </a:prstGeom>
+          <a:noFill/>
+          <a:ln/>
+        </p:spPr>
+        <p:txBody>
+          <a:bodyPr wrap="square" lIns="0" tIns="0" rIns="0" bIns="0" rtlCol="0" anchor="ctr"/>
           <a:lstStyle/>
           <a:p>
             <a:pPr algn="l" indent="0" marL="0">
@@ -3036,7 +3036,7 @@
         </p:nvSpPr>
         <p:spPr>
           <a:xfrm>
-            <a:off x="609600" y="3571875"/>
+            <a:off x="609600" y="3743325"/>
             <a:ext cx="66675" cy="66675"/>
           </a:xfrm>
           <a:prstGeom prst="roundRect">
@@ -3063,17 +3063,17 @@
         </p:nvSpPr>
         <p:spPr>
           <a:xfrm>
-            <a:off x="800100" y="3486150"/>
-            <a:ext cx="5086350" cy="342900"/>
-          </a:xfrm>
-          <a:prstGeom prst="rect">
-            <a:avLst/>
-          </a:prstGeom>
-          <a:noFill/>
-          <a:ln/>
-        </p:spPr>
-        <p:txBody>
-          <a:bodyPr wrap="square" lIns="0" tIns="0" rIns="0" bIns="0" rtlCol="0" anchor="t"/>
+            <a:off x="800100" y="3571875"/>
+            <a:ext cx="5086350" cy="419100"/>
+          </a:xfrm>
+          <a:prstGeom prst="rect">
+            <a:avLst/>
+          </a:prstGeom>
+          <a:noFill/>
+          <a:ln/>
+        </p:spPr>
+        <p:txBody>
+          <a:bodyPr wrap="square" lIns="0" tIns="0" rIns="0" bIns="0" rtlCol="0" anchor="ctr"/>
           <a:lstStyle/>
           <a:p>
             <a:pPr algn="l" indent="0" marL="0">
@@ -3102,12 +3102,12 @@
         </p:nvSpPr>
         <p:spPr>
           <a:xfrm>
-            <a:off x="6324600" y="1219200"/>
-            <a:ext cx="5467350" cy="5105400"/>
+            <a:off x="6324600" y="1457325"/>
+            <a:ext cx="5467350" cy="4867275"/>
           </a:xfrm>
           <a:prstGeom prst="roundRect">
             <a:avLst>
-              <a:gd name="adj" fmla="val 1791"/>
+              <a:gd name="adj" fmla="val 1879"/>
             </a:avLst>
           </a:prstGeom>
           <a:solidFill>
@@ -3129,7 +3129,7 @@
         </p:nvSpPr>
         <p:spPr>
           <a:xfrm>
-            <a:off x="6324600" y="1219200"/>
+            <a:off x="6324600" y="1457325"/>
             <a:ext cx="5467350" cy="76200"/>
           </a:xfrm>
           <a:prstGeom prst="rect">
@@ -3154,7 +3154,7 @@
         </p:nvSpPr>
         <p:spPr>
           <a:xfrm>
-            <a:off x="6534150" y="1447800"/>
+            <a:off x="6534150" y="1685925"/>
             <a:ext cx="5048250" cy="171450"/>
           </a:xfrm>
           <a:prstGeom prst="rect">
@@ -3193,7 +3193,7 @@
         </p:nvSpPr>
         <p:spPr>
           <a:xfrm>
-            <a:off x="6534150" y="1743075"/>
+            <a:off x="6534150" y="1981200"/>
             <a:ext cx="5048250" cy="476250"/>
           </a:xfrm>
           <a:prstGeom prst="rect">
@@ -3232,7 +3232,7 @@
         </p:nvSpPr>
         <p:spPr>
           <a:xfrm>
-            <a:off x="6534150" y="2505075"/>
+            <a:off x="6534150" y="2828925"/>
             <a:ext cx="66675" cy="66675"/>
           </a:xfrm>
           <a:prstGeom prst="roundRect">
@@ -3259,17 +3259,17 @@
         </p:nvSpPr>
         <p:spPr>
           <a:xfrm>
-            <a:off x="6724650" y="2419350"/>
-            <a:ext cx="4857750" cy="342900"/>
-          </a:xfrm>
-          <a:prstGeom prst="rect">
-            <a:avLst/>
-          </a:prstGeom>
-          <a:noFill/>
-          <a:ln/>
-        </p:spPr>
-        <p:txBody>
-          <a:bodyPr wrap="square" lIns="0" tIns="0" rIns="0" bIns="0" rtlCol="0" anchor="t"/>
+            <a:off x="6724650" y="2657475"/>
+            <a:ext cx="4857750" cy="419100"/>
+          </a:xfrm>
+          <a:prstGeom prst="rect">
+            <a:avLst/>
+          </a:prstGeom>
+          <a:noFill/>
+          <a:ln/>
+        </p:spPr>
+        <p:txBody>
+          <a:bodyPr wrap="square" lIns="0" tIns="0" rIns="0" bIns="0" rtlCol="0" anchor="ctr"/>
           <a:lstStyle/>
           <a:p>
             <a:pPr algn="l" indent="0" marL="0">
@@ -3298,7 +3298,7 @@
         </p:nvSpPr>
         <p:spPr>
           <a:xfrm>
-            <a:off x="6534150" y="3038475"/>
+            <a:off x="6534150" y="3286125"/>
             <a:ext cx="66675" cy="66675"/>
           </a:xfrm>
           <a:prstGeom prst="roundRect">
@@ -3325,17 +3325,17 @@
         </p:nvSpPr>
         <p:spPr>
           <a:xfrm>
-            <a:off x="6724650" y="2952750"/>
-            <a:ext cx="4857750" cy="342900"/>
-          </a:xfrm>
-          <a:prstGeom prst="rect">
-            <a:avLst/>
-          </a:prstGeom>
-          <a:noFill/>
-          <a:ln/>
-        </p:spPr>
-        <p:txBody>
-          <a:bodyPr wrap="square" lIns="0" tIns="0" rIns="0" bIns="0" rtlCol="0" anchor="t"/>
+            <a:off x="6724650" y="3114675"/>
+            <a:ext cx="4857750" cy="419100"/>
+          </a:xfrm>
+          <a:prstGeom prst="rect">
+            <a:avLst/>
+          </a:prstGeom>
+          <a:noFill/>
+          <a:ln/>
+        </p:spPr>
+        <p:txBody>
+          <a:bodyPr wrap="square" lIns="0" tIns="0" rIns="0" bIns="0" rtlCol="0" anchor="ctr"/>
           <a:lstStyle/>
           <a:p>
             <a:pPr algn="l" indent="0" marL="0">
@@ -3364,7 +3364,7 @@
         </p:nvSpPr>
         <p:spPr>
           <a:xfrm>
-            <a:off x="6534150" y="3571875"/>
+            <a:off x="6534150" y="3743325"/>
             <a:ext cx="66675" cy="66675"/>
           </a:xfrm>
           <a:prstGeom prst="roundRect">
@@ -3391,17 +3391,17 @@
         </p:nvSpPr>
         <p:spPr>
           <a:xfrm>
-            <a:off x="6724650" y="3486150"/>
-            <a:ext cx="4857750" cy="342900"/>
-          </a:xfrm>
-          <a:prstGeom prst="rect">
-            <a:avLst/>
-          </a:prstGeom>
-          <a:noFill/>
-          <a:ln/>
-        </p:spPr>
-        <p:txBody>
-          <a:bodyPr wrap="square" lIns="0" tIns="0" rIns="0" bIns="0" rtlCol="0" anchor="t"/>
+            <a:off x="6724650" y="3571875"/>
+            <a:ext cx="4857750" cy="419100"/>
+          </a:xfrm>
+          <a:prstGeom prst="rect">
+            <a:avLst/>
+          </a:prstGeom>
+          <a:noFill/>
+          <a:ln/>
+        </p:spPr>
+        <p:txBody>
+          <a:bodyPr wrap="square" lIns="0" tIns="0" rIns="0" bIns="0" rtlCol="0" anchor="ctr"/>
           <a:lstStyle/>
           <a:p>
             <a:pPr algn="l" indent="0" marL="0">
@@ -3493,7 +3493,7 @@
         <p:spPr>
           <a:xfrm>
             <a:off x="400050" y="247650"/>
-            <a:ext cx="10839450" cy="381000"/>
+            <a:ext cx="10839450" cy="428625"/>
           </a:xfrm>
           <a:prstGeom prst="rect">
             <a:avLst/>
@@ -3509,7 +3509,7 @@
               <a:buNone/>
             </a:pPr>
             <a:r>
-              <a:rPr lang="en-US" sz="3000" b="1" dirty="0">
+              <a:rPr lang="en-US" sz="3200" b="1" dirty="0">
                 <a:solidFill>
                   <a:srgbClr val="EAEAEA"/>
                 </a:solidFill>
@@ -3519,7 +3519,7 @@
               </a:rPr>
               <a:t>Clearance already destroys more margin than promo</a:t>
             </a:r>
-            <a:endParaRPr lang="en-US" sz="3000" dirty="0"/>
+            <a:endParaRPr lang="en-US" sz="3200" dirty="0"/>
           </a:p>
         </p:txBody>
       </p:sp>
@@ -3609,12 +3609,12 @@
         </p:nvSpPr>
         <p:spPr>
           <a:xfrm>
-            <a:off x="400050" y="781050"/>
-            <a:ext cx="7058025" cy="5543550"/>
+            <a:off x="400050" y="904875"/>
+            <a:ext cx="7058025" cy="5419725"/>
           </a:xfrm>
           <a:prstGeom prst="roundRect">
             <a:avLst>
-              <a:gd name="adj" fmla="val 1649"/>
+              <a:gd name="adj" fmla="val 1687"/>
             </a:avLst>
           </a:prstGeom>
           <a:solidFill>
@@ -3644,7 +3644,7 @@
         </p:blipFill>
         <p:spPr>
           <a:xfrm>
-            <a:off x="552450" y="2019300"/>
+            <a:off x="552450" y="2085975"/>
             <a:ext cx="6753225" cy="3067050"/>
           </a:xfrm>
           <a:prstGeom prst="rect">
@@ -3660,7 +3660,7 @@
         </p:nvSpPr>
         <p:spPr>
           <a:xfrm>
-            <a:off x="7743825" y="781050"/>
+            <a:off x="7743825" y="904875"/>
             <a:ext cx="4048125" cy="171450"/>
           </a:xfrm>
           <a:prstGeom prst="rect">
@@ -3699,7 +3699,7 @@
         </p:nvSpPr>
         <p:spPr>
           <a:xfrm>
-            <a:off x="7743825" y="1209675"/>
+            <a:off x="7743825" y="1419225"/>
             <a:ext cx="66675" cy="66675"/>
           </a:xfrm>
           <a:prstGeom prst="roundRect">
@@ -3726,17 +3726,17 @@
         </p:nvSpPr>
         <p:spPr>
           <a:xfrm>
-            <a:off x="7934325" y="1123950"/>
-            <a:ext cx="3857625" cy="342900"/>
-          </a:xfrm>
-          <a:prstGeom prst="rect">
-            <a:avLst/>
-          </a:prstGeom>
-          <a:noFill/>
-          <a:ln/>
-        </p:spPr>
-        <p:txBody>
-          <a:bodyPr wrap="square" lIns="0" tIns="0" rIns="0" bIns="0" rtlCol="0" anchor="t"/>
+            <a:off x="7934325" y="1247775"/>
+            <a:ext cx="3857625" cy="419100"/>
+          </a:xfrm>
+          <a:prstGeom prst="rect">
+            <a:avLst/>
+          </a:prstGeom>
+          <a:noFill/>
+          <a:ln/>
+        </p:spPr>
+        <p:txBody>
+          <a:bodyPr wrap="square" lIns="0" tIns="0" rIns="0" bIns="0" rtlCol="0" anchor="ctr"/>
           <a:lstStyle/>
           <a:p>
             <a:pPr algn="l" indent="0" marL="0">
@@ -3765,7 +3765,7 @@
         </p:nvSpPr>
         <p:spPr>
           <a:xfrm>
-            <a:off x="7743825" y="1743075"/>
+            <a:off x="7743825" y="1876425"/>
             <a:ext cx="66675" cy="66675"/>
           </a:xfrm>
           <a:prstGeom prst="roundRect">
@@ -3792,17 +3792,17 @@
         </p:nvSpPr>
         <p:spPr>
           <a:xfrm>
-            <a:off x="7934325" y="1657350"/>
-            <a:ext cx="3857625" cy="342900"/>
-          </a:xfrm>
-          <a:prstGeom prst="rect">
-            <a:avLst/>
-          </a:prstGeom>
-          <a:noFill/>
-          <a:ln/>
-        </p:spPr>
-        <p:txBody>
-          <a:bodyPr wrap="square" lIns="0" tIns="0" rIns="0" bIns="0" rtlCol="0" anchor="t"/>
+            <a:off x="7934325" y="1704975"/>
+            <a:ext cx="3857625" cy="419100"/>
+          </a:xfrm>
+          <a:prstGeom prst="rect">
+            <a:avLst/>
+          </a:prstGeom>
+          <a:noFill/>
+          <a:ln/>
+        </p:spPr>
+        <p:txBody>
+          <a:bodyPr wrap="square" lIns="0" tIns="0" rIns="0" bIns="0" rtlCol="0" anchor="ctr"/>
           <a:lstStyle/>
           <a:p>
             <a:pPr algn="l" indent="0" marL="0">
@@ -3831,7 +3831,7 @@
         </p:nvSpPr>
         <p:spPr>
           <a:xfrm>
-            <a:off x="7743825" y="2276475"/>
+            <a:off x="7743825" y="2333625"/>
             <a:ext cx="66675" cy="66675"/>
           </a:xfrm>
           <a:prstGeom prst="roundRect">
@@ -3858,17 +3858,17 @@
         </p:nvSpPr>
         <p:spPr>
           <a:xfrm>
-            <a:off x="7934325" y="2190750"/>
-            <a:ext cx="3857625" cy="342900"/>
-          </a:xfrm>
-          <a:prstGeom prst="rect">
-            <a:avLst/>
-          </a:prstGeom>
-          <a:noFill/>
-          <a:ln/>
-        </p:spPr>
-        <p:txBody>
-          <a:bodyPr wrap="square" lIns="0" tIns="0" rIns="0" bIns="0" rtlCol="0" anchor="t"/>
+            <a:off x="7934325" y="2162175"/>
+            <a:ext cx="3857625" cy="419100"/>
+          </a:xfrm>
+          <a:prstGeom prst="rect">
+            <a:avLst/>
+          </a:prstGeom>
+          <a:noFill/>
+          <a:ln/>
+        </p:spPr>
+        <p:txBody>
+          <a:bodyPr wrap="square" lIns="0" tIns="0" rIns="0" bIns="0" rtlCol="0" anchor="ctr"/>
           <a:lstStyle/>
           <a:p>
             <a:pPr algn="l" indent="0" marL="0">
@@ -3960,7 +3960,7 @@
         <p:spPr>
           <a:xfrm>
             <a:off x="400050" y="247650"/>
-            <a:ext cx="10839450" cy="381000"/>
+            <a:ext cx="10839450" cy="428625"/>
           </a:xfrm>
           <a:prstGeom prst="rect">
             <a:avLst/>
@@ -3976,7 +3976,7 @@
               <a:buNone/>
             </a:pPr>
             <a:r>
-              <a:rPr lang="en-US" sz="3000" b="1" dirty="0">
+              <a:rPr lang="en-US" sz="3200" b="1" dirty="0">
                 <a:solidFill>
                   <a:srgbClr val="EAEAEA"/>
                 </a:solidFill>
@@ -3986,7 +3986,7 @@
               </a:rPr>
               <a:t>Full-price mix is eroding</a:t>
             </a:r>
-            <a:endParaRPr lang="en-US" sz="3000" dirty="0"/>
+            <a:endParaRPr lang="en-US" sz="3200" dirty="0"/>
           </a:p>
         </p:txBody>
       </p:sp>
@@ -4229,7 +4229,7 @@
         <p:spPr>
           <a:xfrm>
             <a:off x="400050" y="247650"/>
-            <a:ext cx="10839450" cy="381000"/>
+            <a:ext cx="10839450" cy="428625"/>
           </a:xfrm>
           <a:prstGeom prst="rect">
             <a:avLst/>
@@ -4245,7 +4245,7 @@
               <a:buNone/>
             </a:pPr>
             <a:r>
-              <a:rPr lang="en-US" sz="3000" b="1" dirty="0">
+              <a:rPr lang="en-US" sz="3200" b="1" dirty="0">
                 <a:solidFill>
                   <a:srgbClr val="EAEAEA"/>
                 </a:solidFill>
@@ -4255,7 +4255,7 @@
               </a:rPr>
               <a:t>Where to act — and what it buys</a:t>
             </a:r>
-            <a:endParaRPr lang="en-US" sz="3000" dirty="0"/>
+            <a:endParaRPr lang="en-US" sz="3200" dirty="0"/>
           </a:p>
         </p:txBody>
       </p:sp>
@@ -4345,8 +4345,8 @@
         </p:nvSpPr>
         <p:spPr>
           <a:xfrm>
-            <a:off x="400050" y="819150"/>
-            <a:ext cx="5619750" cy="171450"/>
+            <a:off x="400050" y="962025"/>
+            <a:ext cx="6410325" cy="171450"/>
           </a:xfrm>
           <a:prstGeom prst="rect">
             <a:avLst/>
@@ -4384,12 +4384,12 @@
         </p:nvSpPr>
         <p:spPr>
           <a:xfrm>
-            <a:off x="1543050" y="1143000"/>
-            <a:ext cx="2047875" cy="2266950"/>
+            <a:off x="1085850" y="1266825"/>
+            <a:ext cx="2757488" cy="2290763"/>
           </a:xfrm>
           <a:prstGeom prst="roundRect">
             <a:avLst>
-              <a:gd name="adj" fmla="val 4465"/>
+              <a:gd name="adj" fmla="val 3992"/>
             </a:avLst>
           </a:prstGeom>
           <a:solidFill>
@@ -4411,12 +4411,12 @@
         </p:nvSpPr>
         <p:spPr>
           <a:xfrm>
-            <a:off x="3686175" y="1143000"/>
-            <a:ext cx="2047875" cy="2266950"/>
+            <a:off x="3938588" y="1266825"/>
+            <a:ext cx="2757488" cy="2290763"/>
           </a:xfrm>
           <a:prstGeom prst="roundRect">
             <a:avLst>
-              <a:gd name="adj" fmla="val 4465"/>
+              <a:gd name="adj" fmla="val 3992"/>
             </a:avLst>
           </a:prstGeom>
           <a:solidFill>
@@ -4438,12 +4438,12 @@
         </p:nvSpPr>
         <p:spPr>
           <a:xfrm>
-            <a:off x="1543050" y="3505200"/>
-            <a:ext cx="2047875" cy="2266950"/>
+            <a:off x="1085850" y="3652838"/>
+            <a:ext cx="2757488" cy="2290763"/>
           </a:xfrm>
           <a:prstGeom prst="roundRect">
             <a:avLst>
-              <a:gd name="adj" fmla="val 4465"/>
+              <a:gd name="adj" fmla="val 3992"/>
             </a:avLst>
           </a:prstGeom>
           <a:solidFill>
@@ -4465,12 +4465,12 @@
         </p:nvSpPr>
         <p:spPr>
           <a:xfrm>
-            <a:off x="3686175" y="3505200"/>
-            <a:ext cx="2047875" cy="2266950"/>
+            <a:off x="3938588" y="3652838"/>
+            <a:ext cx="2757488" cy="2290763"/>
           </a:xfrm>
           <a:prstGeom prst="roundRect">
             <a:avLst>
-              <a:gd name="adj" fmla="val 4465"/>
+              <a:gd name="adj" fmla="val 3992"/>
             </a:avLst>
           </a:prstGeom>
           <a:solidFill>
@@ -4492,8 +4492,8 @@
         </p:nvSpPr>
         <p:spPr>
           <a:xfrm>
-            <a:off x="400050" y="1143000"/>
-            <a:ext cx="1047750" cy="266700"/>
+            <a:off x="400050" y="1266825"/>
+            <a:ext cx="628650" cy="266700"/>
           </a:xfrm>
           <a:prstGeom prst="rect">
             <a:avLst/>
@@ -4531,8 +4531,8 @@
         </p:nvSpPr>
         <p:spPr>
           <a:xfrm>
-            <a:off x="1543050" y="5924550"/>
-            <a:ext cx="4191000" cy="266700"/>
+            <a:off x="1085850" y="6000750"/>
+            <a:ext cx="5610225" cy="228600"/>
           </a:xfrm>
           <a:prstGeom prst="rect">
             <a:avLst/>
@@ -4570,8 +4570,8 @@
         </p:nvSpPr>
         <p:spPr>
           <a:xfrm>
-            <a:off x="1695450" y="1276350"/>
-            <a:ext cx="1743075" cy="171450"/>
+            <a:off x="1238250" y="1400175"/>
+            <a:ext cx="2452688" cy="171450"/>
           </a:xfrm>
           <a:prstGeom prst="rect">
             <a:avLst/>
@@ -4609,8 +4609,8 @@
         </p:nvSpPr>
         <p:spPr>
           <a:xfrm>
-            <a:off x="3838575" y="1276350"/>
-            <a:ext cx="1743075" cy="171450"/>
+            <a:off x="4090987" y="1400175"/>
+            <a:ext cx="2452688" cy="171450"/>
           </a:xfrm>
           <a:prstGeom prst="rect">
             <a:avLst/>
@@ -4648,8 +4648,8 @@
         </p:nvSpPr>
         <p:spPr>
           <a:xfrm>
-            <a:off x="1695450" y="3638550"/>
-            <a:ext cx="1743075" cy="171450"/>
+            <a:off x="1238250" y="3786188"/>
+            <a:ext cx="2452688" cy="171450"/>
           </a:xfrm>
           <a:prstGeom prst="rect">
             <a:avLst/>
@@ -4687,8 +4687,8 @@
         </p:nvSpPr>
         <p:spPr>
           <a:xfrm>
-            <a:off x="3838575" y="3638550"/>
-            <a:ext cx="1743075" cy="171450"/>
+            <a:off x="4090987" y="3786188"/>
+            <a:ext cx="2452688" cy="171450"/>
           </a:xfrm>
           <a:prstGeom prst="rect">
             <a:avLst/>
@@ -4726,12 +4726,12 @@
         </p:nvSpPr>
         <p:spPr>
           <a:xfrm>
-            <a:off x="1695450" y="1562100"/>
-            <a:ext cx="1743075" cy="381000"/>
+            <a:off x="1200150" y="1685925"/>
+            <a:ext cx="2528888" cy="400050"/>
           </a:xfrm>
           <a:prstGeom prst="roundRect">
             <a:avLst>
-              <a:gd name="adj" fmla="val 24000"/>
+              <a:gd name="adj" fmla="val 22857"/>
             </a:avLst>
           </a:prstGeom>
           <a:solidFill>
@@ -4753,8 +4753,8 @@
         </p:nvSpPr>
         <p:spPr>
           <a:xfrm>
-            <a:off x="1809750" y="1562100"/>
-            <a:ext cx="1514475" cy="381000"/>
+            <a:off x="1295400" y="1685925"/>
+            <a:ext cx="2338388" cy="400050"/>
           </a:xfrm>
           <a:prstGeom prst="rect">
             <a:avLst/>
@@ -4770,7 +4770,7 @@
               <a:buNone/>
             </a:pPr>
             <a:r>
-              <a:rPr lang="en-US" sz="1600" b="1" dirty="0">
+              <a:rPr lang="en-US" sz="1500" b="1" dirty="0">
                 <a:solidFill>
                   <a:srgbClr val="EAEAEA"/>
                 </a:solidFill>
@@ -4780,7 +4780,7 @@
               </a:rPr>
               <a:t>Core basics</a:t>
             </a:r>
-            <a:endParaRPr lang="en-US" sz="1600" dirty="0"/>
+            <a:endParaRPr lang="en-US" sz="1500" dirty="0"/>
           </a:p>
         </p:txBody>
       </p:sp>
@@ -4792,12 +4792,12 @@
         </p:nvSpPr>
         <p:spPr>
           <a:xfrm>
-            <a:off x="3838575" y="1562100"/>
-            <a:ext cx="1743075" cy="381000"/>
+            <a:off x="4052888" y="1685925"/>
+            <a:ext cx="2528888" cy="400050"/>
           </a:xfrm>
           <a:prstGeom prst="roundRect">
             <a:avLst>
-              <a:gd name="adj" fmla="val 24000"/>
+              <a:gd name="adj" fmla="val 22857"/>
             </a:avLst>
           </a:prstGeom>
           <a:solidFill>
@@ -4819,8 +4819,8 @@
         </p:nvSpPr>
         <p:spPr>
           <a:xfrm>
-            <a:off x="3952875" y="1562100"/>
-            <a:ext cx="1514475" cy="381000"/>
+            <a:off x="4148137" y="1685925"/>
+            <a:ext cx="2338388" cy="400050"/>
           </a:xfrm>
           <a:prstGeom prst="rect">
             <a:avLst/>
@@ -4836,7 +4836,7 @@
               <a:buNone/>
             </a:pPr>
             <a:r>
-              <a:rPr lang="en-US" sz="1600" b="1" dirty="0">
+              <a:rPr lang="en-US" sz="1500" b="1" dirty="0">
                 <a:solidFill>
                   <a:srgbClr val="EAEAEA"/>
                 </a:solidFill>
@@ -4846,7 +4846,7 @@
               </a:rPr>
               <a:t>Seasonal fashion</a:t>
             </a:r>
-            <a:endParaRPr lang="en-US" sz="1600" dirty="0"/>
+            <a:endParaRPr lang="en-US" sz="1500" dirty="0"/>
           </a:p>
         </p:txBody>
       </p:sp>
@@ -4858,12 +4858,12 @@
         </p:nvSpPr>
         <p:spPr>
           <a:xfrm>
-            <a:off x="1695450" y="3924300"/>
-            <a:ext cx="1743075" cy="381000"/>
+            <a:off x="1200150" y="4071938"/>
+            <a:ext cx="2528888" cy="400050"/>
           </a:xfrm>
           <a:prstGeom prst="roundRect">
             <a:avLst>
-              <a:gd name="adj" fmla="val 24000"/>
+              <a:gd name="adj" fmla="val 22857"/>
             </a:avLst>
           </a:prstGeom>
           <a:solidFill>
@@ -4885,8 +4885,8 @@
         </p:nvSpPr>
         <p:spPr>
           <a:xfrm>
-            <a:off x="1809750" y="3924300"/>
-            <a:ext cx="1514475" cy="381000"/>
+            <a:off x="1295400" y="4071938"/>
+            <a:ext cx="2338388" cy="400050"/>
           </a:xfrm>
           <a:prstGeom prst="rect">
             <a:avLst/>
@@ -4902,7 +4902,7 @@
               <a:buNone/>
             </a:pPr>
             <a:r>
-              <a:rPr lang="en-US" sz="1600" b="1" dirty="0">
+              <a:rPr lang="en-US" sz="1500" b="1" dirty="0">
                 <a:solidFill>
                   <a:srgbClr val="EAEAEA"/>
                 </a:solidFill>
@@ -4912,7 +4912,7 @@
               </a:rPr>
               <a:t>Test capsules</a:t>
             </a:r>
-            <a:endParaRPr lang="en-US" sz="1600" dirty="0"/>
+            <a:endParaRPr lang="en-US" sz="1500" dirty="0"/>
           </a:p>
         </p:txBody>
       </p:sp>
@@ -4924,12 +4924,12 @@
         </p:nvSpPr>
         <p:spPr>
           <a:xfrm>
-            <a:off x="3838575" y="3924300"/>
-            <a:ext cx="1743075" cy="381000"/>
+            <a:off x="4052888" y="4071938"/>
+            <a:ext cx="2528888" cy="400050"/>
           </a:xfrm>
           <a:prstGeom prst="roundRect">
             <a:avLst>
-              <a:gd name="adj" fmla="val 24000"/>
+              <a:gd name="adj" fmla="val 22857"/>
             </a:avLst>
           </a:prstGeom>
           <a:solidFill>
@@ -4951,8 +4951,8 @@
         </p:nvSpPr>
         <p:spPr>
           <a:xfrm>
-            <a:off x="3952875" y="3924300"/>
-            <a:ext cx="1514475" cy="381000"/>
+            <a:off x="4148137" y="4071938"/>
+            <a:ext cx="2338388" cy="400050"/>
           </a:xfrm>
           <a:prstGeom prst="rect">
             <a:avLst/>
@@ -4968,7 +4968,7 @@
               <a:buNone/>
             </a:pPr>
             <a:r>
-              <a:rPr lang="en-US" sz="1600" b="1" dirty="0">
+              <a:rPr lang="en-US" sz="1500" b="1" dirty="0">
                 <a:solidFill>
                   <a:srgbClr val="EAEAEA"/>
                 </a:solidFill>
@@ -4978,7 +4978,7 @@
               </a:rPr>
               <a:t>Aged novelty</a:t>
             </a:r>
-            <a:endParaRPr lang="en-US" sz="1600" dirty="0"/>
+            <a:endParaRPr lang="en-US" sz="1500" dirty="0"/>
           </a:p>
         </p:txBody>
       </p:sp>
@@ -4990,8 +4990,8 @@
         </p:nvSpPr>
         <p:spPr>
           <a:xfrm>
-            <a:off x="6172200" y="819150"/>
-            <a:ext cx="5619750" cy="171450"/>
+            <a:off x="7038975" y="962025"/>
+            <a:ext cx="4752975" cy="171450"/>
           </a:xfrm>
           <a:prstGeom prst="rect">
             <a:avLst/>
@@ -5029,12 +5029,12 @@
         </p:nvSpPr>
         <p:spPr>
           <a:xfrm>
-            <a:off x="6172200" y="2247900"/>
-            <a:ext cx="1714500" cy="2857500"/>
+            <a:off x="7038975" y="1228725"/>
+            <a:ext cx="4752975" cy="1333500"/>
           </a:xfrm>
           <a:prstGeom prst="roundRect">
             <a:avLst>
-              <a:gd name="adj" fmla="val 5333"/>
+              <a:gd name="adj" fmla="val 6857"/>
             </a:avLst>
           </a:prstGeom>
           <a:solidFill>
@@ -5056,8 +5056,8 @@
         </p:nvSpPr>
         <p:spPr>
           <a:xfrm>
-            <a:off x="6172200" y="2247900"/>
-            <a:ext cx="1714500" cy="76200"/>
+            <a:off x="7038975" y="1228725"/>
+            <a:ext cx="4752975" cy="76200"/>
           </a:xfrm>
           <a:prstGeom prst="rect">
             <a:avLst/>
@@ -5081,8 +5081,8 @@
         </p:nvSpPr>
         <p:spPr>
           <a:xfrm>
-            <a:off x="6362700" y="2495550"/>
-            <a:ext cx="1333500" cy="171450"/>
+            <a:off x="7191375" y="1419225"/>
+            <a:ext cx="4448175" cy="171450"/>
           </a:xfrm>
           <a:prstGeom prst="rect">
             <a:avLst/>
@@ -5120,24 +5120,24 @@
         </p:nvSpPr>
         <p:spPr>
           <a:xfrm>
-            <a:off x="6362700" y="2895600"/>
-            <a:ext cx="1333500" cy="1524000"/>
-          </a:xfrm>
-          <a:prstGeom prst="rect">
-            <a:avLst/>
-          </a:prstGeom>
-          <a:noFill/>
-          <a:ln/>
-        </p:spPr>
-        <p:txBody>
-          <a:bodyPr wrap="none" lIns="0" tIns="0" rIns="0" bIns="0" rtlCol="0" anchor="ctr"/>
-          <a:lstStyle/>
-          <a:p>
-            <a:pPr algn="l" indent="0" marL="0">
-              <a:buNone/>
-            </a:pPr>
-            <a:r>
-              <a:rPr lang="en-US" sz="3000" b="1" dirty="0">
+            <a:off x="7191375" y="1704975"/>
+            <a:ext cx="4448175" cy="381000"/>
+          </a:xfrm>
+          <a:prstGeom prst="rect">
+            <a:avLst/>
+          </a:prstGeom>
+          <a:noFill/>
+          <a:ln/>
+        </p:spPr>
+        <p:txBody>
+          <a:bodyPr wrap="square" lIns="0" tIns="0" rIns="0" bIns="0" rtlCol="0" anchor="ctr"/>
+          <a:lstStyle/>
+          <a:p>
+            <a:pPr algn="l" indent="0" marL="0">
+              <a:buNone/>
+            </a:pPr>
+            <a:r>
+              <a:rPr lang="en-US" sz="2500" b="1" dirty="0">
                 <a:solidFill>
                   <a:srgbClr val="4E79A7"/>
                 </a:solidFill>
@@ -5145,9 +5145,9 @@
                 <a:ea typeface="Helvetica Neue" pitchFamily="34" charset="-122"/>
                 <a:cs typeface="Helvetica Neue" pitchFamily="34" charset="-120"/>
               </a:rPr>
-              <a:t>+$18–28M</a:t>
-            </a:r>
-            <a:endParaRPr lang="en-US" sz="3000" dirty="0"/>
+              <a:t>+$23M</a:t>
+            </a:r>
+            <a:endParaRPr lang="en-US" sz="2500" dirty="0"/>
           </a:p>
         </p:txBody>
       </p:sp>
@@ -5159,8 +5159,8 @@
         </p:nvSpPr>
         <p:spPr>
           <a:xfrm>
-            <a:off x="6362700" y="4552950"/>
-            <a:ext cx="1333500" cy="381000"/>
+            <a:off x="7191375" y="2143125"/>
+            <a:ext cx="4448175" cy="304800"/>
           </a:xfrm>
           <a:prstGeom prst="rect">
             <a:avLst/>
@@ -5176,7 +5176,7 @@
               <a:buNone/>
             </a:pPr>
             <a:r>
-              <a:rPr lang="en-US" sz="1300" dirty="0">
+              <a:rPr lang="en-US" sz="1200" dirty="0">
                 <a:solidFill>
                   <a:srgbClr val="6C6C8A"/>
                 </a:solidFill>
@@ -5184,9 +5184,9 @@
                 <a:ea typeface="Helvetica Neue" pitchFamily="34" charset="-122"/>
                 <a:cs typeface="Helvetica Neue" pitchFamily="34" charset="-120"/>
               </a:rPr>
-              <a:t>Gross profit</a:t>
-            </a:r>
-            <a:endParaRPr lang="en-US" sz="1300" dirty="0"/>
+              <a:t>Mid-case GP uplift</a:t>
+            </a:r>
+            <a:endParaRPr lang="en-US" sz="1200" dirty="0"/>
           </a:p>
         </p:txBody>
       </p:sp>
@@ -5198,12 +5198,12 @@
         </p:nvSpPr>
         <p:spPr>
           <a:xfrm>
-            <a:off x="8115300" y="2247900"/>
-            <a:ext cx="1714500" cy="2857500"/>
+            <a:off x="7038975" y="2676525"/>
+            <a:ext cx="4752975" cy="1333500"/>
           </a:xfrm>
           <a:prstGeom prst="roundRect">
             <a:avLst>
-              <a:gd name="adj" fmla="val 5333"/>
+              <a:gd name="adj" fmla="val 6857"/>
             </a:avLst>
           </a:prstGeom>
           <a:solidFill>
@@ -5225,8 +5225,8 @@
         </p:nvSpPr>
         <p:spPr>
           <a:xfrm>
-            <a:off x="8115300" y="2247900"/>
-            <a:ext cx="1714500" cy="76200"/>
+            <a:off x="7038975" y="2676525"/>
+            <a:ext cx="4752975" cy="76200"/>
           </a:xfrm>
           <a:prstGeom prst="rect">
             <a:avLst/>
@@ -5250,8 +5250,8 @@
         </p:nvSpPr>
         <p:spPr>
           <a:xfrm>
-            <a:off x="8305800" y="2495550"/>
-            <a:ext cx="1333500" cy="171450"/>
+            <a:off x="7191375" y="2867025"/>
+            <a:ext cx="4448175" cy="171450"/>
           </a:xfrm>
           <a:prstGeom prst="rect">
             <a:avLst/>
@@ -5289,24 +5289,24 @@
         </p:nvSpPr>
         <p:spPr>
           <a:xfrm>
-            <a:off x="8305800" y="2895600"/>
-            <a:ext cx="1333500" cy="1524000"/>
-          </a:xfrm>
-          <a:prstGeom prst="rect">
-            <a:avLst/>
-          </a:prstGeom>
-          <a:noFill/>
-          <a:ln/>
-        </p:spPr>
-        <p:txBody>
-          <a:bodyPr wrap="none" lIns="0" tIns="0" rIns="0" bIns="0" rtlCol="0" anchor="ctr"/>
-          <a:lstStyle/>
-          <a:p>
-            <a:pPr algn="l" indent="0" marL="0">
-              <a:buNone/>
-            </a:pPr>
-            <a:r>
-              <a:rPr lang="en-US" sz="3000" b="1" dirty="0">
+            <a:off x="7191375" y="3152775"/>
+            <a:ext cx="4448175" cy="381000"/>
+          </a:xfrm>
+          <a:prstGeom prst="rect">
+            <a:avLst/>
+          </a:prstGeom>
+          <a:noFill/>
+          <a:ln/>
+        </p:spPr>
+        <p:txBody>
+          <a:bodyPr wrap="square" lIns="0" tIns="0" rIns="0" bIns="0" rtlCol="0" anchor="ctr"/>
+          <a:lstStyle/>
+          <a:p>
+            <a:pPr algn="l" indent="0" marL="0">
+              <a:buNone/>
+            </a:pPr>
+            <a:r>
+              <a:rPr lang="en-US" sz="2500" b="1" dirty="0">
                 <a:solidFill>
                   <a:srgbClr val="F28E2B"/>
                 </a:solidFill>
@@ -5314,9 +5314,9 @@
                 <a:ea typeface="Helvetica Neue" pitchFamily="34" charset="-122"/>
                 <a:cs typeface="Helvetica Neue" pitchFamily="34" charset="-120"/>
               </a:rPr>
-              <a:t>+4–6 pts</a:t>
-            </a:r>
-            <a:endParaRPr lang="en-US" sz="3000" dirty="0"/>
+              <a:t>+5 pts</a:t>
+            </a:r>
+            <a:endParaRPr lang="en-US" sz="2500" dirty="0"/>
           </a:p>
         </p:txBody>
       </p:sp>
@@ -5328,8 +5328,8 @@
         </p:nvSpPr>
         <p:spPr>
           <a:xfrm>
-            <a:off x="8305800" y="4552950"/>
-            <a:ext cx="1333500" cy="381000"/>
+            <a:off x="7191375" y="3590925"/>
+            <a:ext cx="4448175" cy="304800"/>
           </a:xfrm>
           <a:prstGeom prst="rect">
             <a:avLst/>
@@ -5345,7 +5345,7 @@
               <a:buNone/>
             </a:pPr>
             <a:r>
-              <a:rPr lang="en-US" sz="1300" dirty="0">
+              <a:rPr lang="en-US" sz="1200" dirty="0">
                 <a:solidFill>
                   <a:srgbClr val="6C6C8A"/>
                 </a:solidFill>
@@ -5355,7 +5355,7 @@
               </a:rPr>
               <a:t>Within 12 months</a:t>
             </a:r>
-            <a:endParaRPr lang="en-US" sz="1300" dirty="0"/>
+            <a:endParaRPr lang="en-US" sz="1200" dirty="0"/>
           </a:p>
         </p:txBody>
       </p:sp>
@@ -5367,12 +5367,12 @@
         </p:nvSpPr>
         <p:spPr>
           <a:xfrm>
-            <a:off x="10058400" y="2247900"/>
-            <a:ext cx="1714500" cy="2857500"/>
+            <a:off x="7038975" y="4124325"/>
+            <a:ext cx="4752975" cy="1333500"/>
           </a:xfrm>
           <a:prstGeom prst="roundRect">
             <a:avLst>
-              <a:gd name="adj" fmla="val 5333"/>
+              <a:gd name="adj" fmla="val 6857"/>
             </a:avLst>
           </a:prstGeom>
           <a:solidFill>
@@ -5394,8 +5394,8 @@
         </p:nvSpPr>
         <p:spPr>
           <a:xfrm>
-            <a:off x="10058400" y="2247900"/>
-            <a:ext cx="1714500" cy="76200"/>
+            <a:off x="7038975" y="4124325"/>
+            <a:ext cx="4752975" cy="76200"/>
           </a:xfrm>
           <a:prstGeom prst="rect">
             <a:avLst/>
@@ -5419,8 +5419,8 @@
         </p:nvSpPr>
         <p:spPr>
           <a:xfrm>
-            <a:off x="10248900" y="2495550"/>
-            <a:ext cx="1333500" cy="171450"/>
+            <a:off x="7191375" y="4314825"/>
+            <a:ext cx="4448175" cy="171450"/>
           </a:xfrm>
           <a:prstGeom prst="rect">
             <a:avLst/>
@@ -5458,24 +5458,24 @@
         </p:nvSpPr>
         <p:spPr>
           <a:xfrm>
-            <a:off x="10248900" y="2895600"/>
-            <a:ext cx="1333500" cy="1524000"/>
-          </a:xfrm>
-          <a:prstGeom prst="rect">
-            <a:avLst/>
-          </a:prstGeom>
-          <a:noFill/>
-          <a:ln/>
-        </p:spPr>
-        <p:txBody>
-          <a:bodyPr wrap="none" lIns="0" tIns="0" rIns="0" bIns="0" rtlCol="0" anchor="ctr"/>
-          <a:lstStyle/>
-          <a:p>
-            <a:pPr algn="l" indent="0" marL="0">
-              <a:buNone/>
-            </a:pPr>
-            <a:r>
-              <a:rPr lang="en-US" sz="3400" b="1" dirty="0">
+            <a:off x="7191375" y="4600575"/>
+            <a:ext cx="4448175" cy="381000"/>
+          </a:xfrm>
+          <a:prstGeom prst="rect">
+            <a:avLst/>
+          </a:prstGeom>
+          <a:noFill/>
+          <a:ln/>
+        </p:spPr>
+        <p:txBody>
+          <a:bodyPr wrap="square" lIns="0" tIns="0" rIns="0" bIns="0" rtlCol="0" anchor="ctr"/>
+          <a:lstStyle/>
+          <a:p>
+            <a:pPr algn="l" indent="0" marL="0">
+              <a:buNone/>
+            </a:pPr>
+            <a:r>
+              <a:rPr lang="en-US" sz="2500" b="1" dirty="0">
                 <a:solidFill>
                   <a:srgbClr val="E15759"/>
                 </a:solidFill>
@@ -5483,9 +5483,9 @@
                 <a:ea typeface="Helvetica Neue" pitchFamily="34" charset="-122"/>
                 <a:cs typeface="Helvetica Neue" pitchFamily="34" charset="-120"/>
               </a:rPr>
-              <a:t>−15–25%</a:t>
-            </a:r>
-            <a:endParaRPr lang="en-US" sz="3400" dirty="0"/>
+              <a:t>−20%</a:t>
+            </a:r>
+            <a:endParaRPr lang="en-US" sz="2500" dirty="0"/>
           </a:p>
         </p:txBody>
       </p:sp>
@@ -5497,8 +5497,8 @@
         </p:nvSpPr>
         <p:spPr>
           <a:xfrm>
-            <a:off x="10248900" y="4552950"/>
-            <a:ext cx="1333500" cy="381000"/>
+            <a:off x="7191375" y="5038725"/>
+            <a:ext cx="4448175" cy="304800"/>
           </a:xfrm>
           <a:prstGeom prst="rect">
             <a:avLst/>
@@ -5514,7 +5514,7 @@
               <a:buNone/>
             </a:pPr>
             <a:r>
-              <a:rPr lang="en-US" sz="1300" dirty="0">
+              <a:rPr lang="en-US" sz="1200" dirty="0">
                 <a:solidFill>
                   <a:srgbClr val="6C6C8A"/>
                 </a:solidFill>
@@ -5524,7 +5524,7 @@
               </a:rPr>
               <a:t>Weeks of supply</a:t>
             </a:r>
-            <a:endParaRPr lang="en-US" sz="1300" dirty="0"/>
+            <a:endParaRPr lang="en-US" sz="1200" dirty="0"/>
           </a:p>
         </p:txBody>
       </p:sp>
@@ -5599,7 +5599,7 @@
         <p:spPr>
           <a:xfrm>
             <a:off x="400050" y="247650"/>
-            <a:ext cx="10839450" cy="381000"/>
+            <a:ext cx="10839450" cy="428625"/>
           </a:xfrm>
           <a:prstGeom prst="rect">
             <a:avLst/>
@@ -5615,7 +5615,7 @@
               <a:buNone/>
             </a:pPr>
             <a:r>
-              <a:rPr lang="en-US" sz="3000" b="1" dirty="0">
+              <a:rPr lang="en-US" sz="3200" b="1" dirty="0">
                 <a:solidFill>
                   <a:srgbClr val="EAEAEA"/>
                 </a:solidFill>
@@ -5625,7 +5625,7 @@
               </a:rPr>
               <a:t>Sequence the capability—not a one-off promo calendar</a:t>
             </a:r>
-            <a:endParaRPr lang="en-US" sz="3000" dirty="0"/>
+            <a:endParaRPr lang="en-US" sz="3200" dirty="0"/>
           </a:p>
         </p:txBody>
       </p:sp>
@@ -5715,8 +5715,8 @@
         </p:nvSpPr>
         <p:spPr>
           <a:xfrm>
-            <a:off x="400050" y="781050"/>
-            <a:ext cx="3667125" cy="5086350"/>
+            <a:off x="400050" y="904875"/>
+            <a:ext cx="3667125" cy="4962525"/>
           </a:xfrm>
           <a:prstGeom prst="roundRect">
             <a:avLst>
@@ -5742,8 +5742,8 @@
         </p:nvSpPr>
         <p:spPr>
           <a:xfrm>
-            <a:off x="400050" y="781050"/>
-            <a:ext cx="57150" cy="5086350"/>
+            <a:off x="400050" y="904875"/>
+            <a:ext cx="57150" cy="4962525"/>
           </a:xfrm>
           <a:prstGeom prst="rect">
             <a:avLst/>
@@ -5767,7 +5767,7 @@
         </p:nvSpPr>
         <p:spPr>
           <a:xfrm>
-            <a:off x="571500" y="952500"/>
+            <a:off x="571500" y="1076325"/>
             <a:ext cx="3324225" cy="171450"/>
           </a:xfrm>
           <a:prstGeom prst="rect">
@@ -5806,7 +5806,7 @@
         </p:nvSpPr>
         <p:spPr>
           <a:xfrm>
-            <a:off x="571500" y="1200150"/>
+            <a:off x="571500" y="1323975"/>
             <a:ext cx="3324225" cy="381000"/>
           </a:xfrm>
           <a:prstGeom prst="rect">
@@ -5845,7 +5845,7 @@
         </p:nvSpPr>
         <p:spPr>
           <a:xfrm>
-            <a:off x="571500" y="1619250"/>
+            <a:off x="571500" y="1743075"/>
             <a:ext cx="3324225" cy="457200"/>
           </a:xfrm>
           <a:prstGeom prst="rect">
@@ -5884,7 +5884,7 @@
         </p:nvSpPr>
         <p:spPr>
           <a:xfrm>
-            <a:off x="571500" y="2200275"/>
+            <a:off x="571500" y="2371725"/>
             <a:ext cx="66675" cy="66675"/>
           </a:xfrm>
           <a:prstGeom prst="roundRect">
@@ -5911,7 +5911,7 @@
         </p:nvSpPr>
         <p:spPr>
           <a:xfrm>
-            <a:off x="762000" y="2114550"/>
+            <a:off x="762000" y="2238375"/>
             <a:ext cx="3133725" cy="342900"/>
           </a:xfrm>
           <a:prstGeom prst="rect">
@@ -5921,7 +5921,7 @@
           <a:ln/>
         </p:spPr>
         <p:txBody>
-          <a:bodyPr wrap="square" lIns="0" tIns="0" rIns="0" bIns="0" rtlCol="0" anchor="t"/>
+          <a:bodyPr wrap="square" lIns="0" tIns="0" rIns="0" bIns="0" rtlCol="0" anchor="ctr"/>
           <a:lstStyle/>
           <a:p>
             <a:pPr algn="l" indent="0" marL="0">
@@ -5950,7 +5950,7 @@
         </p:nvSpPr>
         <p:spPr>
           <a:xfrm>
-            <a:off x="571500" y="2428875"/>
+            <a:off x="571500" y="2600325"/>
             <a:ext cx="66675" cy="66675"/>
           </a:xfrm>
           <a:prstGeom prst="roundRect">
@@ -5977,7 +5977,7 @@
         </p:nvSpPr>
         <p:spPr>
           <a:xfrm>
-            <a:off x="762000" y="2343150"/>
+            <a:off x="762000" y="2466975"/>
             <a:ext cx="3133725" cy="342900"/>
           </a:xfrm>
           <a:prstGeom prst="rect">
@@ -5987,7 +5987,7 @@
           <a:ln/>
         </p:spPr>
         <p:txBody>
-          <a:bodyPr wrap="square" lIns="0" tIns="0" rIns="0" bIns="0" rtlCol="0" anchor="t"/>
+          <a:bodyPr wrap="square" lIns="0" tIns="0" rIns="0" bIns="0" rtlCol="0" anchor="ctr"/>
           <a:lstStyle/>
           <a:p>
             <a:pPr algn="l" indent="0" marL="0">
@@ -6016,7 +6016,7 @@
         </p:nvSpPr>
         <p:spPr>
           <a:xfrm>
-            <a:off x="571500" y="2657475"/>
+            <a:off x="571500" y="2828925"/>
             <a:ext cx="66675" cy="66675"/>
           </a:xfrm>
           <a:prstGeom prst="roundRect">
@@ -6043,7 +6043,7 @@
         </p:nvSpPr>
         <p:spPr>
           <a:xfrm>
-            <a:off x="762000" y="2571750"/>
+            <a:off x="762000" y="2695575"/>
             <a:ext cx="3133725" cy="342900"/>
           </a:xfrm>
           <a:prstGeom prst="rect">
@@ -6053,7 +6053,7 @@
           <a:ln/>
         </p:spPr>
         <p:txBody>
-          <a:bodyPr wrap="square" lIns="0" tIns="0" rIns="0" bIns="0" rtlCol="0" anchor="t"/>
+          <a:bodyPr wrap="square" lIns="0" tIns="0" rIns="0" bIns="0" rtlCol="0" anchor="ctr"/>
           <a:lstStyle/>
           <a:p>
             <a:pPr algn="l" indent="0" marL="0">
@@ -6082,8 +6082,8 @@
         </p:nvSpPr>
         <p:spPr>
           <a:xfrm>
-            <a:off x="4257675" y="781050"/>
-            <a:ext cx="3667125" cy="5086350"/>
+            <a:off x="4257675" y="904875"/>
+            <a:ext cx="3667125" cy="4962525"/>
           </a:xfrm>
           <a:prstGeom prst="roundRect">
             <a:avLst>
@@ -6109,8 +6109,8 @@
         </p:nvSpPr>
         <p:spPr>
           <a:xfrm>
-            <a:off x="4257675" y="781050"/>
-            <a:ext cx="57150" cy="5086350"/>
+            <a:off x="4257675" y="904875"/>
+            <a:ext cx="57150" cy="4962525"/>
           </a:xfrm>
           <a:prstGeom prst="rect">
             <a:avLst/>
@@ -6134,7 +6134,7 @@
         </p:nvSpPr>
         <p:spPr>
           <a:xfrm>
-            <a:off x="4429125" y="952500"/>
+            <a:off x="4429125" y="1076325"/>
             <a:ext cx="3324225" cy="171450"/>
           </a:xfrm>
           <a:prstGeom prst="rect">
@@ -6173,7 +6173,7 @@
         </p:nvSpPr>
         <p:spPr>
           <a:xfrm>
-            <a:off x="4429125" y="1200150"/>
+            <a:off x="4429125" y="1323975"/>
             <a:ext cx="3324225" cy="381000"/>
           </a:xfrm>
           <a:prstGeom prst="rect">
@@ -6212,7 +6212,7 @@
         </p:nvSpPr>
         <p:spPr>
           <a:xfrm>
-            <a:off x="4429125" y="1619250"/>
+            <a:off x="4429125" y="1743075"/>
             <a:ext cx="3324225" cy="457200"/>
           </a:xfrm>
           <a:prstGeom prst="rect">
@@ -6251,7 +6251,7 @@
         </p:nvSpPr>
         <p:spPr>
           <a:xfrm>
-            <a:off x="4429125" y="2200275"/>
+            <a:off x="4429125" y="2371725"/>
             <a:ext cx="66675" cy="66675"/>
           </a:xfrm>
           <a:prstGeom prst="roundRect">
@@ -6278,7 +6278,7 @@
         </p:nvSpPr>
         <p:spPr>
           <a:xfrm>
-            <a:off x="4619625" y="2114550"/>
+            <a:off x="4619625" y="2238375"/>
             <a:ext cx="3133725" cy="342900"/>
           </a:xfrm>
           <a:prstGeom prst="rect">
@@ -6288,7 +6288,7 @@
           <a:ln/>
         </p:spPr>
         <p:txBody>
-          <a:bodyPr wrap="square" lIns="0" tIns="0" rIns="0" bIns="0" rtlCol="0" anchor="t"/>
+          <a:bodyPr wrap="square" lIns="0" tIns="0" rIns="0" bIns="0" rtlCol="0" anchor="ctr"/>
           <a:lstStyle/>
           <a:p>
             <a:pPr algn="l" indent="0" marL="0">
@@ -6317,7 +6317,7 @@
         </p:nvSpPr>
         <p:spPr>
           <a:xfrm>
-            <a:off x="4429125" y="2428875"/>
+            <a:off x="4429125" y="2600325"/>
             <a:ext cx="66675" cy="66675"/>
           </a:xfrm>
           <a:prstGeom prst="roundRect">
@@ -6344,7 +6344,7 @@
         </p:nvSpPr>
         <p:spPr>
           <a:xfrm>
-            <a:off x="4619625" y="2343150"/>
+            <a:off x="4619625" y="2466975"/>
             <a:ext cx="3133725" cy="342900"/>
           </a:xfrm>
           <a:prstGeom prst="rect">
@@ -6354,7 +6354,7 @@
           <a:ln/>
         </p:spPr>
         <p:txBody>
-          <a:bodyPr wrap="square" lIns="0" tIns="0" rIns="0" bIns="0" rtlCol="0" anchor="t"/>
+          <a:bodyPr wrap="square" lIns="0" tIns="0" rIns="0" bIns="0" rtlCol="0" anchor="ctr"/>
           <a:lstStyle/>
           <a:p>
             <a:pPr algn="l" indent="0" marL="0">
@@ -6383,7 +6383,7 @@
         </p:nvSpPr>
         <p:spPr>
           <a:xfrm>
-            <a:off x="4429125" y="2657475"/>
+            <a:off x="4429125" y="2828925"/>
             <a:ext cx="66675" cy="66675"/>
           </a:xfrm>
           <a:prstGeom prst="roundRect">
@@ -6410,7 +6410,7 @@
         </p:nvSpPr>
         <p:spPr>
           <a:xfrm>
-            <a:off x="4619625" y="2571750"/>
+            <a:off x="4619625" y="2695575"/>
             <a:ext cx="3133725" cy="342900"/>
           </a:xfrm>
           <a:prstGeom prst="rect">
@@ -6420,7 +6420,7 @@
           <a:ln/>
         </p:spPr>
         <p:txBody>
-          <a:bodyPr wrap="square" lIns="0" tIns="0" rIns="0" bIns="0" rtlCol="0" anchor="t"/>
+          <a:bodyPr wrap="square" lIns="0" tIns="0" rIns="0" bIns="0" rtlCol="0" anchor="ctr"/>
           <a:lstStyle/>
           <a:p>
             <a:pPr algn="l" indent="0" marL="0">
@@ -6449,8 +6449,8 @@
         </p:nvSpPr>
         <p:spPr>
           <a:xfrm>
-            <a:off x="8115300" y="781050"/>
-            <a:ext cx="3667125" cy="5086350"/>
+            <a:off x="8115300" y="904875"/>
+            <a:ext cx="3667125" cy="4962525"/>
           </a:xfrm>
           <a:prstGeom prst="roundRect">
             <a:avLst>
@@ -6476,8 +6476,8 @@
         </p:nvSpPr>
         <p:spPr>
           <a:xfrm>
-            <a:off x="8115300" y="781050"/>
-            <a:ext cx="57150" cy="5086350"/>
+            <a:off x="8115300" y="904875"/>
+            <a:ext cx="57150" cy="4962525"/>
           </a:xfrm>
           <a:prstGeom prst="rect">
             <a:avLst/>
@@ -6501,7 +6501,7 @@
         </p:nvSpPr>
         <p:spPr>
           <a:xfrm>
-            <a:off x="8286750" y="952500"/>
+            <a:off x="8286750" y="1076325"/>
             <a:ext cx="3324225" cy="171450"/>
           </a:xfrm>
           <a:prstGeom prst="rect">
@@ -6540,7 +6540,7 @@
         </p:nvSpPr>
         <p:spPr>
           <a:xfrm>
-            <a:off x="8286750" y="1200150"/>
+            <a:off x="8286750" y="1323975"/>
             <a:ext cx="3324225" cy="381000"/>
           </a:xfrm>
           <a:prstGeom prst="rect">
@@ -6579,7 +6579,7 @@
         </p:nvSpPr>
         <p:spPr>
           <a:xfrm>
-            <a:off x="8286750" y="1619250"/>
+            <a:off x="8286750" y="1743075"/>
             <a:ext cx="3324225" cy="457200"/>
           </a:xfrm>
           <a:prstGeom prst="rect">
@@ -6618,7 +6618,7 @@
         </p:nvSpPr>
         <p:spPr>
           <a:xfrm>
-            <a:off x="8286750" y="2200275"/>
+            <a:off x="8286750" y="2371725"/>
             <a:ext cx="66675" cy="66675"/>
           </a:xfrm>
           <a:prstGeom prst="roundRect">
@@ -6645,7 +6645,7 @@
         </p:nvSpPr>
         <p:spPr>
           <a:xfrm>
-            <a:off x="8477250" y="2114550"/>
+            <a:off x="8477250" y="2238375"/>
             <a:ext cx="3133725" cy="342900"/>
           </a:xfrm>
           <a:prstGeom prst="rect">
@@ -6655,7 +6655,7 @@
           <a:ln/>
         </p:spPr>
         <p:txBody>
-          <a:bodyPr wrap="square" lIns="0" tIns="0" rIns="0" bIns="0" rtlCol="0" anchor="t"/>
+          <a:bodyPr wrap="square" lIns="0" tIns="0" rIns="0" bIns="0" rtlCol="0" anchor="ctr"/>
           <a:lstStyle/>
           <a:p>
             <a:pPr algn="l" indent="0" marL="0">
@@ -6684,7 +6684,7 @@
         </p:nvSpPr>
         <p:spPr>
           <a:xfrm>
-            <a:off x="8286750" y="2428875"/>
+            <a:off x="8286750" y="2600325"/>
             <a:ext cx="66675" cy="66675"/>
           </a:xfrm>
           <a:prstGeom prst="roundRect">
@@ -6711,7 +6711,7 @@
         </p:nvSpPr>
         <p:spPr>
           <a:xfrm>
-            <a:off x="8477250" y="2343150"/>
+            <a:off x="8477250" y="2466975"/>
             <a:ext cx="3133725" cy="342900"/>
           </a:xfrm>
           <a:prstGeom prst="rect">
@@ -6721,7 +6721,7 @@
           <a:ln/>
         </p:spPr>
         <p:txBody>
-          <a:bodyPr wrap="square" lIns="0" tIns="0" rIns="0" bIns="0" rtlCol="0" anchor="t"/>
+          <a:bodyPr wrap="square" lIns="0" tIns="0" rIns="0" bIns="0" rtlCol="0" anchor="ctr"/>
           <a:lstStyle/>
           <a:p>
             <a:pPr algn="l" indent="0" marL="0">
@@ -6750,7 +6750,7 @@
         </p:nvSpPr>
         <p:spPr>
           <a:xfrm>
-            <a:off x="8286750" y="2657475"/>
+            <a:off x="8286750" y="2828925"/>
             <a:ext cx="66675" cy="66675"/>
           </a:xfrm>
           <a:prstGeom prst="roundRect">
@@ -6777,7 +6777,7 @@
         </p:nvSpPr>
         <p:spPr>
           <a:xfrm>
-            <a:off x="8477250" y="2571750"/>
+            <a:off x="8477250" y="2695575"/>
             <a:ext cx="3133725" cy="342900"/>
           </a:xfrm>
           <a:prstGeom prst="rect">
@@ -6787,7 +6787,7 @@
           <a:ln/>
         </p:spPr>
         <p:txBody>
-          <a:bodyPr wrap="square" lIns="0" tIns="0" rIns="0" bIns="0" rtlCol="0" anchor="t"/>
+          <a:bodyPr wrap="square" lIns="0" tIns="0" rIns="0" bIns="0" rtlCol="0" anchor="ctr"/>
           <a:lstStyle/>
           <a:p>
             <a:pPr algn="l" indent="0" marL="0">
@@ -6918,7 +6918,7 @@
         <p:spPr>
           <a:xfrm>
             <a:off x="400050" y="247650"/>
-            <a:ext cx="10839450" cy="381000"/>
+            <a:ext cx="10839450" cy="428625"/>
           </a:xfrm>
           <a:prstGeom prst="rect">
             <a:avLst/>
@@ -6934,7 +6934,7 @@
               <a:buNone/>
             </a:pPr>
             <a:r>
-              <a:rPr lang="en-US" sz="3000" b="1" dirty="0">
+              <a:rPr lang="en-US" sz="3200" b="1" dirty="0">
                 <a:solidFill>
                   <a:srgbClr val="EAEAEA"/>
                 </a:solidFill>
@@ -6944,7 +6944,7 @@
               </a:rPr>
               <a:t>90-day pilot squad</a:t>
             </a:r>
-            <a:endParaRPr lang="en-US" sz="3000" dirty="0"/>
+            <a:endParaRPr lang="en-US" sz="3200" dirty="0"/>
           </a:p>
         </p:txBody>
       </p:sp>
@@ -6956,8 +6956,8 @@
         </p:nvSpPr>
         <p:spPr>
           <a:xfrm>
-            <a:off x="400050" y="800100"/>
-            <a:ext cx="10648950" cy="266700"/>
+            <a:off x="400050" y="942975"/>
+            <a:ext cx="10648950" cy="285750"/>
           </a:xfrm>
           <a:prstGeom prst="rect">
             <a:avLst/>
@@ -7073,7 +7073,7 @@
         </p:nvSpPr>
         <p:spPr>
           <a:xfrm>
-            <a:off x="1905000" y="1219200"/>
+            <a:off x="1905000" y="1457325"/>
             <a:ext cx="3168650" cy="171450"/>
           </a:xfrm>
           <a:prstGeom prst="rect">
@@ -7112,7 +7112,7 @@
         </p:nvSpPr>
         <p:spPr>
           <a:xfrm>
-            <a:off x="5226050" y="1219200"/>
+            <a:off x="5226050" y="1457325"/>
             <a:ext cx="3168650" cy="171450"/>
           </a:xfrm>
           <a:prstGeom prst="rect">
@@ -7151,7 +7151,7 @@
         </p:nvSpPr>
         <p:spPr>
           <a:xfrm>
-            <a:off x="8547100" y="1219200"/>
+            <a:off x="8547100" y="1457325"/>
             <a:ext cx="3168650" cy="171450"/>
           </a:xfrm>
           <a:prstGeom prst="rect">
@@ -7190,8 +7190,8 @@
         </p:nvSpPr>
         <p:spPr>
           <a:xfrm>
-            <a:off x="400050" y="1562100"/>
-            <a:ext cx="1257300" cy="876300"/>
+            <a:off x="400050" y="1800225"/>
+            <a:ext cx="1257300" cy="828675"/>
           </a:xfrm>
           <a:prstGeom prst="rect">
             <a:avLst/>
@@ -7229,8 +7229,8 @@
         </p:nvSpPr>
         <p:spPr>
           <a:xfrm>
-            <a:off x="1828800" y="1562100"/>
-            <a:ext cx="9963150" cy="876300"/>
+            <a:off x="1828800" y="1800225"/>
+            <a:ext cx="9963150" cy="828675"/>
           </a:xfrm>
           <a:prstGeom prst="rect">
             <a:avLst/>
@@ -7254,8 +7254,8 @@
         </p:nvSpPr>
         <p:spPr>
           <a:xfrm>
-            <a:off x="400050" y="2514600"/>
-            <a:ext cx="1257300" cy="876300"/>
+            <a:off x="400050" y="2705100"/>
+            <a:ext cx="1257300" cy="828675"/>
           </a:xfrm>
           <a:prstGeom prst="rect">
             <a:avLst/>
@@ -7293,8 +7293,8 @@
         </p:nvSpPr>
         <p:spPr>
           <a:xfrm>
-            <a:off x="1828800" y="2514600"/>
-            <a:ext cx="9963150" cy="876300"/>
+            <a:off x="1828800" y="2705100"/>
+            <a:ext cx="9963150" cy="828675"/>
           </a:xfrm>
           <a:prstGeom prst="rect">
             <a:avLst/>
@@ -7318,8 +7318,8 @@
         </p:nvSpPr>
         <p:spPr>
           <a:xfrm>
-            <a:off x="400050" y="3467100"/>
-            <a:ext cx="1257300" cy="876300"/>
+            <a:off x="400050" y="3609975"/>
+            <a:ext cx="1257300" cy="828675"/>
           </a:xfrm>
           <a:prstGeom prst="rect">
             <a:avLst/>
@@ -7357,8 +7357,8 @@
         </p:nvSpPr>
         <p:spPr>
           <a:xfrm>
-            <a:off x="1828800" y="3467100"/>
-            <a:ext cx="9963150" cy="876300"/>
+            <a:off x="1828800" y="3609975"/>
+            <a:ext cx="9963150" cy="828675"/>
           </a:xfrm>
           <a:prstGeom prst="rect">
             <a:avLst/>
@@ -7382,8 +7382,8 @@
         </p:nvSpPr>
         <p:spPr>
           <a:xfrm>
-            <a:off x="400050" y="4419600"/>
-            <a:ext cx="1257300" cy="876300"/>
+            <a:off x="400050" y="4514850"/>
+            <a:ext cx="1257300" cy="828675"/>
           </a:xfrm>
           <a:prstGeom prst="rect">
             <a:avLst/>
@@ -7421,8 +7421,8 @@
         </p:nvSpPr>
         <p:spPr>
           <a:xfrm>
-            <a:off x="1828800" y="4419600"/>
-            <a:ext cx="9963150" cy="876300"/>
+            <a:off x="1828800" y="4514850"/>
+            <a:ext cx="9963150" cy="828675"/>
           </a:xfrm>
           <a:prstGeom prst="rect">
             <a:avLst/>
@@ -7446,8 +7446,8 @@
         </p:nvSpPr>
         <p:spPr>
           <a:xfrm>
-            <a:off x="400050" y="5372100"/>
-            <a:ext cx="1257300" cy="876300"/>
+            <a:off x="400050" y="5419725"/>
+            <a:ext cx="1257300" cy="828675"/>
           </a:xfrm>
           <a:prstGeom prst="rect">
             <a:avLst/>
@@ -7485,8 +7485,8 @@
         </p:nvSpPr>
         <p:spPr>
           <a:xfrm>
-            <a:off x="1828800" y="5372100"/>
-            <a:ext cx="9963150" cy="876300"/>
+            <a:off x="1828800" y="5419725"/>
+            <a:ext cx="9963150" cy="828675"/>
           </a:xfrm>
           <a:prstGeom prst="rect">
             <a:avLst/>
@@ -7510,7 +7510,7 @@
         </p:nvSpPr>
         <p:spPr>
           <a:xfrm>
-            <a:off x="1924050" y="1809750"/>
+            <a:off x="1924050" y="2024062"/>
             <a:ext cx="3130550" cy="381000"/>
           </a:xfrm>
           <a:prstGeom prst="roundRect">
@@ -7537,7 +7537,7 @@
         </p:nvSpPr>
         <p:spPr>
           <a:xfrm>
-            <a:off x="2000250" y="1809750"/>
+            <a:off x="2000250" y="2024062"/>
             <a:ext cx="2978150" cy="381000"/>
           </a:xfrm>
           <a:prstGeom prst="rect">
@@ -7576,7 +7576,7 @@
         </p:nvSpPr>
         <p:spPr>
           <a:xfrm>
-            <a:off x="1924050" y="2762250"/>
+            <a:off x="1924050" y="2928938"/>
             <a:ext cx="3130550" cy="381000"/>
           </a:xfrm>
           <a:prstGeom prst="roundRect">
@@ -7603,7 +7603,7 @@
         </p:nvSpPr>
         <p:spPr>
           <a:xfrm>
-            <a:off x="2000250" y="2762250"/>
+            <a:off x="2000250" y="2928938"/>
             <a:ext cx="2978150" cy="381000"/>
           </a:xfrm>
           <a:prstGeom prst="rect">
@@ -7642,7 +7642,7 @@
         </p:nvSpPr>
         <p:spPr>
           <a:xfrm>
-            <a:off x="5245100" y="3714750"/>
+            <a:off x="5245100" y="3833812"/>
             <a:ext cx="3130550" cy="381000"/>
           </a:xfrm>
           <a:prstGeom prst="roundRect">
@@ -7669,7 +7669,7 @@
         </p:nvSpPr>
         <p:spPr>
           <a:xfrm>
-            <a:off x="5321300" y="3714750"/>
+            <a:off x="5321300" y="3833812"/>
             <a:ext cx="2978150" cy="381000"/>
           </a:xfrm>
           <a:prstGeom prst="rect">
@@ -7708,7 +7708,7 @@
         </p:nvSpPr>
         <p:spPr>
           <a:xfrm>
-            <a:off x="5245100" y="4667250"/>
+            <a:off x="5245100" y="4738688"/>
             <a:ext cx="3130550" cy="381000"/>
           </a:xfrm>
           <a:prstGeom prst="roundRect">
@@ -7735,7 +7735,7 @@
         </p:nvSpPr>
         <p:spPr>
           <a:xfrm>
-            <a:off x="5321300" y="4667250"/>
+            <a:off x="5321300" y="4738688"/>
             <a:ext cx="2978150" cy="381000"/>
           </a:xfrm>
           <a:prstGeom prst="rect">
@@ -7774,7 +7774,7 @@
         </p:nvSpPr>
         <p:spPr>
           <a:xfrm>
-            <a:off x="8566150" y="5619750"/>
+            <a:off x="8566150" y="5643563"/>
             <a:ext cx="3130550" cy="381000"/>
           </a:xfrm>
           <a:prstGeom prst="roundRect">
@@ -7801,7 +7801,7 @@
         </p:nvSpPr>
         <p:spPr>
           <a:xfrm>
-            <a:off x="8642350" y="5619750"/>
+            <a:off x="8642350" y="5643563"/>
             <a:ext cx="2978150" cy="381000"/>
           </a:xfrm>
           <a:prstGeom prst="rect">
@@ -7941,8 +7941,8 @@
         </p:nvSpPr>
         <p:spPr>
           <a:xfrm>
-            <a:off x="400050" y="1238250"/>
-            <a:ext cx="9525000" cy="1333500"/>
+            <a:off x="400050" y="1143000"/>
+            <a:ext cx="9525000" cy="1371600"/>
           </a:xfrm>
           <a:prstGeom prst="rect">
             <a:avLst/>
@@ -8003,8 +8003,8 @@
         </p:nvSpPr>
         <p:spPr>
           <a:xfrm>
-            <a:off x="400050" y="2952750"/>
-            <a:ext cx="8572500" cy="571500"/>
+            <a:off x="400050" y="2781300"/>
+            <a:ext cx="8572500" cy="342900"/>
           </a:xfrm>
           <a:prstGeom prst="rect">
             <a:avLst/>
@@ -8094,7 +8094,7 @@
         </p:nvSpPr>
         <p:spPr>
           <a:xfrm>
-            <a:off x="571500" y="4152900"/>
+            <a:off x="571500" y="4114800"/>
             <a:ext cx="3105150" cy="171450"/>
           </a:xfrm>
           <a:prstGeom prst="rect">
@@ -8133,8 +8133,8 @@
         </p:nvSpPr>
         <p:spPr>
           <a:xfrm>
-            <a:off x="571500" y="4419600"/>
-            <a:ext cx="3105150" cy="571500"/>
+            <a:off x="571500" y="4362450"/>
+            <a:ext cx="3105150" cy="666750"/>
           </a:xfrm>
           <a:prstGeom prst="rect">
             <a:avLst/>
@@ -8224,7 +8224,7 @@
         </p:nvSpPr>
         <p:spPr>
           <a:xfrm>
-            <a:off x="4343400" y="4152900"/>
+            <a:off x="4343400" y="4114800"/>
             <a:ext cx="3105150" cy="171450"/>
           </a:xfrm>
           <a:prstGeom prst="rect">
@@ -8263,8 +8263,8 @@
         </p:nvSpPr>
         <p:spPr>
           <a:xfrm>
-            <a:off x="4343400" y="4419600"/>
-            <a:ext cx="3105150" cy="571500"/>
+            <a:off x="4343400" y="4362450"/>
+            <a:ext cx="3105150" cy="666750"/>
           </a:xfrm>
           <a:prstGeom prst="rect">
             <a:avLst/>
@@ -8354,7 +8354,7 @@
         </p:nvSpPr>
         <p:spPr>
           <a:xfrm>
-            <a:off x="8115300" y="4152900"/>
+            <a:off x="8115300" y="4114800"/>
             <a:ext cx="3105150" cy="171450"/>
           </a:xfrm>
           <a:prstGeom prst="rect">
@@ -8393,8 +8393,8 @@
         </p:nvSpPr>
         <p:spPr>
           <a:xfrm>
-            <a:off x="8115300" y="4419600"/>
-            <a:ext cx="3105150" cy="571500"/>
+            <a:off x="8115300" y="4362450"/>
+            <a:ext cx="3105150" cy="666750"/>
           </a:xfrm>
           <a:prstGeom prst="rect">
             <a:avLst/>

</xml_diff>

<commit_message>
Add layout policy knobs and richer CSV chart/table media.
Shared align/font/chrome spacing tokens make nested compose defaults more consistent; media.table, hbar, and stacked bars round out the CSV-to-PPTX path.

Co-authored-by: Cursor <cursoragent@cursor.com>
</commit_message>
<xml_diff>
--- a/examples/apparel-markdown.pptx
+++ b/examples/apparel-markdown.pptx
@@ -1726,7 +1726,7 @@
         </p:nvSpPr>
         <p:spPr>
           <a:xfrm>
-            <a:off x="400050" y="2038350"/>
+            <a:off x="400050" y="2114550"/>
             <a:ext cx="6858000" cy="457200"/>
           </a:xfrm>
           <a:prstGeom prst="rect">
@@ -1765,7 +1765,7 @@
         </p:nvSpPr>
         <p:spPr>
           <a:xfrm>
-            <a:off x="400050" y="2686050"/>
+            <a:off x="400050" y="2914650"/>
             <a:ext cx="1238250" cy="285750"/>
           </a:xfrm>
           <a:prstGeom prst="roundRect">
@@ -1792,7 +1792,7 @@
         </p:nvSpPr>
         <p:spPr>
           <a:xfrm>
-            <a:off x="476250" y="2743200"/>
+            <a:off x="476250" y="2971800"/>
             <a:ext cx="1085850" cy="171450"/>
           </a:xfrm>
           <a:prstGeom prst="rect">
@@ -1831,7 +1831,7 @@
         </p:nvSpPr>
         <p:spPr>
           <a:xfrm>
-            <a:off x="400050" y="3105150"/>
+            <a:off x="400050" y="3333750"/>
             <a:ext cx="6667500" cy="342900"/>
           </a:xfrm>
           <a:prstGeom prst="rect">
@@ -2774,12 +2774,12 @@
         </p:nvSpPr>
         <p:spPr>
           <a:xfrm>
-            <a:off x="400050" y="1457325"/>
-            <a:ext cx="5695950" cy="4867275"/>
+            <a:off x="400050" y="1419225"/>
+            <a:ext cx="5695950" cy="4905375"/>
           </a:xfrm>
           <a:prstGeom prst="roundRect">
             <a:avLst>
-              <a:gd name="adj" fmla="val 1879"/>
+              <a:gd name="adj" fmla="val 1864"/>
             </a:avLst>
           </a:prstGeom>
           <a:solidFill>
@@ -2801,7 +2801,7 @@
         </p:nvSpPr>
         <p:spPr>
           <a:xfrm>
-            <a:off x="400050" y="1457325"/>
+            <a:off x="400050" y="1419225"/>
             <a:ext cx="5695950" cy="76200"/>
           </a:xfrm>
           <a:prstGeom prst="rect">
@@ -2826,7 +2826,7 @@
         </p:nvSpPr>
         <p:spPr>
           <a:xfrm>
-            <a:off x="609600" y="1685925"/>
+            <a:off x="609600" y="1647825"/>
             <a:ext cx="5276850" cy="171450"/>
           </a:xfrm>
           <a:prstGeom prst="rect">
@@ -2865,7 +2865,7 @@
         </p:nvSpPr>
         <p:spPr>
           <a:xfrm>
-            <a:off x="609600" y="1981200"/>
+            <a:off x="609600" y="1943100"/>
             <a:ext cx="5276850" cy="476250"/>
           </a:xfrm>
           <a:prstGeom prst="rect">
@@ -2904,7 +2904,7 @@
         </p:nvSpPr>
         <p:spPr>
           <a:xfrm>
-            <a:off x="609600" y="2828925"/>
+            <a:off x="609600" y="2790825"/>
             <a:ext cx="66675" cy="66675"/>
           </a:xfrm>
           <a:prstGeom prst="roundRect">
@@ -2931,7 +2931,7 @@
         </p:nvSpPr>
         <p:spPr>
           <a:xfrm>
-            <a:off x="800100" y="2657475"/>
+            <a:off x="800100" y="2619375"/>
             <a:ext cx="5086350" cy="419100"/>
           </a:xfrm>
           <a:prstGeom prst="rect">
@@ -2970,7 +2970,7 @@
         </p:nvSpPr>
         <p:spPr>
           <a:xfrm>
-            <a:off x="609600" y="3286125"/>
+            <a:off x="609600" y="3248025"/>
             <a:ext cx="66675" cy="66675"/>
           </a:xfrm>
           <a:prstGeom prst="roundRect">
@@ -2997,7 +2997,7 @@
         </p:nvSpPr>
         <p:spPr>
           <a:xfrm>
-            <a:off x="800100" y="3114675"/>
+            <a:off x="800100" y="3076575"/>
             <a:ext cx="5086350" cy="419100"/>
           </a:xfrm>
           <a:prstGeom prst="rect">
@@ -3036,7 +3036,7 @@
         </p:nvSpPr>
         <p:spPr>
           <a:xfrm>
-            <a:off x="609600" y="3743325"/>
+            <a:off x="609600" y="3705225"/>
             <a:ext cx="66675" cy="66675"/>
           </a:xfrm>
           <a:prstGeom prst="roundRect">
@@ -3063,7 +3063,7 @@
         </p:nvSpPr>
         <p:spPr>
           <a:xfrm>
-            <a:off x="800100" y="3571875"/>
+            <a:off x="800100" y="3533775"/>
             <a:ext cx="5086350" cy="419100"/>
           </a:xfrm>
           <a:prstGeom prst="rect">
@@ -3102,12 +3102,12 @@
         </p:nvSpPr>
         <p:spPr>
           <a:xfrm>
-            <a:off x="6324600" y="1457325"/>
-            <a:ext cx="5467350" cy="4867275"/>
+            <a:off x="6324600" y="1419225"/>
+            <a:ext cx="5467350" cy="4905375"/>
           </a:xfrm>
           <a:prstGeom prst="roundRect">
             <a:avLst>
-              <a:gd name="adj" fmla="val 1879"/>
+              <a:gd name="adj" fmla="val 1864"/>
             </a:avLst>
           </a:prstGeom>
           <a:solidFill>
@@ -3129,7 +3129,7 @@
         </p:nvSpPr>
         <p:spPr>
           <a:xfrm>
-            <a:off x="6324600" y="1457325"/>
+            <a:off x="6324600" y="1419225"/>
             <a:ext cx="5467350" cy="76200"/>
           </a:xfrm>
           <a:prstGeom prst="rect">
@@ -3154,7 +3154,7 @@
         </p:nvSpPr>
         <p:spPr>
           <a:xfrm>
-            <a:off x="6534150" y="1685925"/>
+            <a:off x="6534150" y="1647825"/>
             <a:ext cx="5048250" cy="171450"/>
           </a:xfrm>
           <a:prstGeom prst="rect">
@@ -3193,7 +3193,7 @@
         </p:nvSpPr>
         <p:spPr>
           <a:xfrm>
-            <a:off x="6534150" y="1981200"/>
+            <a:off x="6534150" y="1943100"/>
             <a:ext cx="5048250" cy="476250"/>
           </a:xfrm>
           <a:prstGeom prst="rect">
@@ -3232,7 +3232,7 @@
         </p:nvSpPr>
         <p:spPr>
           <a:xfrm>
-            <a:off x="6534150" y="2828925"/>
+            <a:off x="6534150" y="2790825"/>
             <a:ext cx="66675" cy="66675"/>
           </a:xfrm>
           <a:prstGeom prst="roundRect">
@@ -3259,7 +3259,7 @@
         </p:nvSpPr>
         <p:spPr>
           <a:xfrm>
-            <a:off x="6724650" y="2657475"/>
+            <a:off x="6724650" y="2619375"/>
             <a:ext cx="4857750" cy="419100"/>
           </a:xfrm>
           <a:prstGeom prst="rect">
@@ -3298,7 +3298,7 @@
         </p:nvSpPr>
         <p:spPr>
           <a:xfrm>
-            <a:off x="6534150" y="3286125"/>
+            <a:off x="6534150" y="3248025"/>
             <a:ext cx="66675" cy="66675"/>
           </a:xfrm>
           <a:prstGeom prst="roundRect">
@@ -3325,7 +3325,7 @@
         </p:nvSpPr>
         <p:spPr>
           <a:xfrm>
-            <a:off x="6724650" y="3114675"/>
+            <a:off x="6724650" y="3076575"/>
             <a:ext cx="4857750" cy="419100"/>
           </a:xfrm>
           <a:prstGeom prst="rect">
@@ -3364,7 +3364,7 @@
         </p:nvSpPr>
         <p:spPr>
           <a:xfrm>
-            <a:off x="6534150" y="3743325"/>
+            <a:off x="6534150" y="3705225"/>
             <a:ext cx="66675" cy="66675"/>
           </a:xfrm>
           <a:prstGeom prst="roundRect">
@@ -3391,7 +3391,7 @@
         </p:nvSpPr>
         <p:spPr>
           <a:xfrm>
-            <a:off x="6724650" y="3571875"/>
+            <a:off x="6724650" y="3533775"/>
             <a:ext cx="4857750" cy="419100"/>
           </a:xfrm>
           <a:prstGeom prst="rect">
@@ -3609,12 +3609,12 @@
         </p:nvSpPr>
         <p:spPr>
           <a:xfrm>
-            <a:off x="400050" y="904875"/>
-            <a:ext cx="7058025" cy="5419725"/>
+            <a:off x="400050" y="866775"/>
+            <a:ext cx="7058025" cy="5457825"/>
           </a:xfrm>
           <a:prstGeom prst="roundRect">
             <a:avLst>
-              <a:gd name="adj" fmla="val 1687"/>
+              <a:gd name="adj" fmla="val 1675"/>
             </a:avLst>
           </a:prstGeom>
           <a:solidFill>
@@ -3644,7 +3644,7 @@
         </p:blipFill>
         <p:spPr>
           <a:xfrm>
-            <a:off x="552450" y="2085975"/>
+            <a:off x="552450" y="2066925"/>
             <a:ext cx="6753225" cy="3067050"/>
           </a:xfrm>
           <a:prstGeom prst="rect">
@@ -3660,7 +3660,7 @@
         </p:nvSpPr>
         <p:spPr>
           <a:xfrm>
-            <a:off x="7743825" y="904875"/>
+            <a:off x="7743825" y="866775"/>
             <a:ext cx="4048125" cy="171450"/>
           </a:xfrm>
           <a:prstGeom prst="rect">
@@ -3699,7 +3699,7 @@
         </p:nvSpPr>
         <p:spPr>
           <a:xfrm>
-            <a:off x="7743825" y="1419225"/>
+            <a:off x="7743825" y="1381125"/>
             <a:ext cx="66675" cy="66675"/>
           </a:xfrm>
           <a:prstGeom prst="roundRect">
@@ -3726,7 +3726,7 @@
         </p:nvSpPr>
         <p:spPr>
           <a:xfrm>
-            <a:off x="7934325" y="1247775"/>
+            <a:off x="7934325" y="1209675"/>
             <a:ext cx="3857625" cy="419100"/>
           </a:xfrm>
           <a:prstGeom prst="rect">
@@ -3765,7 +3765,7 @@
         </p:nvSpPr>
         <p:spPr>
           <a:xfrm>
-            <a:off x="7743825" y="1876425"/>
+            <a:off x="7743825" y="1838325"/>
             <a:ext cx="66675" cy="66675"/>
           </a:xfrm>
           <a:prstGeom prst="roundRect">
@@ -3792,7 +3792,7 @@
         </p:nvSpPr>
         <p:spPr>
           <a:xfrm>
-            <a:off x="7934325" y="1704975"/>
+            <a:off x="7934325" y="1666875"/>
             <a:ext cx="3857625" cy="419100"/>
           </a:xfrm>
           <a:prstGeom prst="rect">
@@ -3831,7 +3831,7 @@
         </p:nvSpPr>
         <p:spPr>
           <a:xfrm>
-            <a:off x="7743825" y="2333625"/>
+            <a:off x="7743825" y="2295525"/>
             <a:ext cx="66675" cy="66675"/>
           </a:xfrm>
           <a:prstGeom prst="roundRect">
@@ -3858,7 +3858,7 @@
         </p:nvSpPr>
         <p:spPr>
           <a:xfrm>
-            <a:off x="7934325" y="2162175"/>
+            <a:off x="7934325" y="2124075"/>
             <a:ext cx="3857625" cy="419100"/>
           </a:xfrm>
           <a:prstGeom prst="rect">
@@ -4345,7 +4345,7 @@
         </p:nvSpPr>
         <p:spPr>
           <a:xfrm>
-            <a:off x="400050" y="962025"/>
+            <a:off x="400050" y="981075"/>
             <a:ext cx="6410325" cy="171450"/>
           </a:xfrm>
           <a:prstGeom prst="rect">
@@ -4384,12 +4384,12 @@
         </p:nvSpPr>
         <p:spPr>
           <a:xfrm>
-            <a:off x="1085850" y="1266825"/>
-            <a:ext cx="2757488" cy="2290763"/>
+            <a:off x="1085850" y="1285875"/>
+            <a:ext cx="2757488" cy="2281238"/>
           </a:xfrm>
           <a:prstGeom prst="roundRect">
             <a:avLst>
-              <a:gd name="adj" fmla="val 3992"/>
+              <a:gd name="adj" fmla="val 4008"/>
             </a:avLst>
           </a:prstGeom>
           <a:solidFill>
@@ -4411,12 +4411,12 @@
         </p:nvSpPr>
         <p:spPr>
           <a:xfrm>
-            <a:off x="3938588" y="1266825"/>
-            <a:ext cx="2757488" cy="2290763"/>
+            <a:off x="3938588" y="1285875"/>
+            <a:ext cx="2757488" cy="2281238"/>
           </a:xfrm>
           <a:prstGeom prst="roundRect">
             <a:avLst>
-              <a:gd name="adj" fmla="val 3992"/>
+              <a:gd name="adj" fmla="val 4008"/>
             </a:avLst>
           </a:prstGeom>
           <a:solidFill>
@@ -4438,12 +4438,12 @@
         </p:nvSpPr>
         <p:spPr>
           <a:xfrm>
-            <a:off x="1085850" y="3652838"/>
-            <a:ext cx="2757488" cy="2290763"/>
+            <a:off x="1085850" y="3662362"/>
+            <a:ext cx="2757488" cy="2281238"/>
           </a:xfrm>
           <a:prstGeom prst="roundRect">
             <a:avLst>
-              <a:gd name="adj" fmla="val 3992"/>
+              <a:gd name="adj" fmla="val 4008"/>
             </a:avLst>
           </a:prstGeom>
           <a:solidFill>
@@ -4465,12 +4465,12 @@
         </p:nvSpPr>
         <p:spPr>
           <a:xfrm>
-            <a:off x="3938588" y="3652838"/>
-            <a:ext cx="2757488" cy="2290763"/>
+            <a:off x="3938588" y="3662362"/>
+            <a:ext cx="2757488" cy="2281238"/>
           </a:xfrm>
           <a:prstGeom prst="roundRect">
             <a:avLst>
-              <a:gd name="adj" fmla="val 3992"/>
+              <a:gd name="adj" fmla="val 4008"/>
             </a:avLst>
           </a:prstGeom>
           <a:solidFill>
@@ -4492,7 +4492,7 @@
         </p:nvSpPr>
         <p:spPr>
           <a:xfrm>
-            <a:off x="400050" y="1266825"/>
+            <a:off x="400050" y="1285875"/>
             <a:ext cx="628650" cy="266700"/>
           </a:xfrm>
           <a:prstGeom prst="rect">
@@ -4570,7 +4570,7 @@
         </p:nvSpPr>
         <p:spPr>
           <a:xfrm>
-            <a:off x="1238250" y="1400175"/>
+            <a:off x="1238250" y="1419225"/>
             <a:ext cx="2452688" cy="171450"/>
           </a:xfrm>
           <a:prstGeom prst="rect">
@@ -4609,7 +4609,7 @@
         </p:nvSpPr>
         <p:spPr>
           <a:xfrm>
-            <a:off x="4090987" y="1400175"/>
+            <a:off x="4090987" y="1419225"/>
             <a:ext cx="2452688" cy="171450"/>
           </a:xfrm>
           <a:prstGeom prst="rect">
@@ -4648,7 +4648,7 @@
         </p:nvSpPr>
         <p:spPr>
           <a:xfrm>
-            <a:off x="1238250" y="3786188"/>
+            <a:off x="1238250" y="3795713"/>
             <a:ext cx="2452688" cy="171450"/>
           </a:xfrm>
           <a:prstGeom prst="rect">
@@ -4687,7 +4687,7 @@
         </p:nvSpPr>
         <p:spPr>
           <a:xfrm>
-            <a:off x="4090987" y="3786188"/>
+            <a:off x="4090987" y="3795713"/>
             <a:ext cx="2452688" cy="171450"/>
           </a:xfrm>
           <a:prstGeom prst="rect">
@@ -4726,7 +4726,7 @@
         </p:nvSpPr>
         <p:spPr>
           <a:xfrm>
-            <a:off x="1200150" y="1685925"/>
+            <a:off x="1200150" y="1704975"/>
             <a:ext cx="2528888" cy="400050"/>
           </a:xfrm>
           <a:prstGeom prst="roundRect">
@@ -4753,7 +4753,7 @@
         </p:nvSpPr>
         <p:spPr>
           <a:xfrm>
-            <a:off x="1295400" y="1685925"/>
+            <a:off x="1295400" y="1704975"/>
             <a:ext cx="2338388" cy="400050"/>
           </a:xfrm>
           <a:prstGeom prst="rect">
@@ -4792,7 +4792,7 @@
         </p:nvSpPr>
         <p:spPr>
           <a:xfrm>
-            <a:off x="4052888" y="1685925"/>
+            <a:off x="4052888" y="1704975"/>
             <a:ext cx="2528888" cy="400050"/>
           </a:xfrm>
           <a:prstGeom prst="roundRect">
@@ -4819,7 +4819,7 @@
         </p:nvSpPr>
         <p:spPr>
           <a:xfrm>
-            <a:off x="4148137" y="1685925"/>
+            <a:off x="4148137" y="1704975"/>
             <a:ext cx="2338388" cy="400050"/>
           </a:xfrm>
           <a:prstGeom prst="rect">
@@ -4858,7 +4858,7 @@
         </p:nvSpPr>
         <p:spPr>
           <a:xfrm>
-            <a:off x="1200150" y="4071938"/>
+            <a:off x="1200150" y="4081463"/>
             <a:ext cx="2528888" cy="400050"/>
           </a:xfrm>
           <a:prstGeom prst="roundRect">
@@ -4885,7 +4885,7 @@
         </p:nvSpPr>
         <p:spPr>
           <a:xfrm>
-            <a:off x="1295400" y="4071938"/>
+            <a:off x="1295400" y="4081463"/>
             <a:ext cx="2338388" cy="400050"/>
           </a:xfrm>
           <a:prstGeom prst="rect">
@@ -4924,7 +4924,7 @@
         </p:nvSpPr>
         <p:spPr>
           <a:xfrm>
-            <a:off x="4052888" y="4071938"/>
+            <a:off x="4052888" y="4081463"/>
             <a:ext cx="2528888" cy="400050"/>
           </a:xfrm>
           <a:prstGeom prst="roundRect">
@@ -4951,7 +4951,7 @@
         </p:nvSpPr>
         <p:spPr>
           <a:xfrm>
-            <a:off x="4148137" y="4071938"/>
+            <a:off x="4148137" y="4081463"/>
             <a:ext cx="2338388" cy="400050"/>
           </a:xfrm>
           <a:prstGeom prst="rect">
@@ -4990,7 +4990,7 @@
         </p:nvSpPr>
         <p:spPr>
           <a:xfrm>
-            <a:off x="7038975" y="962025"/>
+            <a:off x="7038975" y="981075"/>
             <a:ext cx="4752975" cy="171450"/>
           </a:xfrm>
           <a:prstGeom prst="rect">
@@ -5029,7 +5029,7 @@
         </p:nvSpPr>
         <p:spPr>
           <a:xfrm>
-            <a:off x="7038975" y="1228725"/>
+            <a:off x="7038975" y="1247775"/>
             <a:ext cx="4752975" cy="1333500"/>
           </a:xfrm>
           <a:prstGeom prst="roundRect">
@@ -5056,7 +5056,7 @@
         </p:nvSpPr>
         <p:spPr>
           <a:xfrm>
-            <a:off x="7038975" y="1228725"/>
+            <a:off x="7038975" y="1247775"/>
             <a:ext cx="4752975" cy="76200"/>
           </a:xfrm>
           <a:prstGeom prst="rect">
@@ -5081,7 +5081,7 @@
         </p:nvSpPr>
         <p:spPr>
           <a:xfrm>
-            <a:off x="7191375" y="1419225"/>
+            <a:off x="7191375" y="1438275"/>
             <a:ext cx="4448175" cy="171450"/>
           </a:xfrm>
           <a:prstGeom prst="rect">
@@ -5120,7 +5120,7 @@
         </p:nvSpPr>
         <p:spPr>
           <a:xfrm>
-            <a:off x="7191375" y="1704975"/>
+            <a:off x="7191375" y="1724025"/>
             <a:ext cx="4448175" cy="381000"/>
           </a:xfrm>
           <a:prstGeom prst="rect">
@@ -5159,7 +5159,7 @@
         </p:nvSpPr>
         <p:spPr>
           <a:xfrm>
-            <a:off x="7191375" y="2143125"/>
+            <a:off x="7191375" y="2162175"/>
             <a:ext cx="4448175" cy="304800"/>
           </a:xfrm>
           <a:prstGeom prst="rect">
@@ -5198,7 +5198,7 @@
         </p:nvSpPr>
         <p:spPr>
           <a:xfrm>
-            <a:off x="7038975" y="2676525"/>
+            <a:off x="7038975" y="2695575"/>
             <a:ext cx="4752975" cy="1333500"/>
           </a:xfrm>
           <a:prstGeom prst="roundRect">
@@ -5225,7 +5225,7 @@
         </p:nvSpPr>
         <p:spPr>
           <a:xfrm>
-            <a:off x="7038975" y="2676525"/>
+            <a:off x="7038975" y="2695575"/>
             <a:ext cx="4752975" cy="76200"/>
           </a:xfrm>
           <a:prstGeom prst="rect">
@@ -5250,7 +5250,7 @@
         </p:nvSpPr>
         <p:spPr>
           <a:xfrm>
-            <a:off x="7191375" y="2867025"/>
+            <a:off x="7191375" y="2886075"/>
             <a:ext cx="4448175" cy="171450"/>
           </a:xfrm>
           <a:prstGeom prst="rect">
@@ -5289,7 +5289,7 @@
         </p:nvSpPr>
         <p:spPr>
           <a:xfrm>
-            <a:off x="7191375" y="3152775"/>
+            <a:off x="7191375" y="3171825"/>
             <a:ext cx="4448175" cy="381000"/>
           </a:xfrm>
           <a:prstGeom prst="rect">
@@ -5328,7 +5328,7 @@
         </p:nvSpPr>
         <p:spPr>
           <a:xfrm>
-            <a:off x="7191375" y="3590925"/>
+            <a:off x="7191375" y="3609975"/>
             <a:ext cx="4448175" cy="304800"/>
           </a:xfrm>
           <a:prstGeom prst="rect">
@@ -5367,7 +5367,7 @@
         </p:nvSpPr>
         <p:spPr>
           <a:xfrm>
-            <a:off x="7038975" y="4124325"/>
+            <a:off x="7038975" y="4143375"/>
             <a:ext cx="4752975" cy="1333500"/>
           </a:xfrm>
           <a:prstGeom prst="roundRect">
@@ -5394,7 +5394,7 @@
         </p:nvSpPr>
         <p:spPr>
           <a:xfrm>
-            <a:off x="7038975" y="4124325"/>
+            <a:off x="7038975" y="4143375"/>
             <a:ext cx="4752975" cy="76200"/>
           </a:xfrm>
           <a:prstGeom prst="rect">
@@ -5419,7 +5419,7 @@
         </p:nvSpPr>
         <p:spPr>
           <a:xfrm>
-            <a:off x="7191375" y="4314825"/>
+            <a:off x="7191375" y="4333875"/>
             <a:ext cx="4448175" cy="171450"/>
           </a:xfrm>
           <a:prstGeom prst="rect">
@@ -5458,7 +5458,7 @@
         </p:nvSpPr>
         <p:spPr>
           <a:xfrm>
-            <a:off x="7191375" y="4600575"/>
+            <a:off x="7191375" y="4619625"/>
             <a:ext cx="4448175" cy="381000"/>
           </a:xfrm>
           <a:prstGeom prst="rect">
@@ -5497,7 +5497,7 @@
         </p:nvSpPr>
         <p:spPr>
           <a:xfrm>
-            <a:off x="7191375" y="5038725"/>
+            <a:off x="7191375" y="5057775"/>
             <a:ext cx="4448175" cy="304800"/>
           </a:xfrm>
           <a:prstGeom prst="rect">
@@ -5715,8 +5715,8 @@
         </p:nvSpPr>
         <p:spPr>
           <a:xfrm>
-            <a:off x="400050" y="904875"/>
-            <a:ext cx="3667125" cy="4962525"/>
+            <a:off x="400050" y="866775"/>
+            <a:ext cx="3667125" cy="5000625"/>
           </a:xfrm>
           <a:prstGeom prst="roundRect">
             <a:avLst>
@@ -5742,8 +5742,8 @@
         </p:nvSpPr>
         <p:spPr>
           <a:xfrm>
-            <a:off x="400050" y="904875"/>
-            <a:ext cx="57150" cy="4962525"/>
+            <a:off x="400050" y="866775"/>
+            <a:ext cx="57150" cy="5000625"/>
           </a:xfrm>
           <a:prstGeom prst="rect">
             <a:avLst/>
@@ -5767,7 +5767,7 @@
         </p:nvSpPr>
         <p:spPr>
           <a:xfrm>
-            <a:off x="571500" y="1076325"/>
+            <a:off x="571500" y="1038225"/>
             <a:ext cx="3324225" cy="171450"/>
           </a:xfrm>
           <a:prstGeom prst="rect">
@@ -5806,7 +5806,7 @@
         </p:nvSpPr>
         <p:spPr>
           <a:xfrm>
-            <a:off x="571500" y="1323975"/>
+            <a:off x="571500" y="1285875"/>
             <a:ext cx="3324225" cy="381000"/>
           </a:xfrm>
           <a:prstGeom prst="rect">
@@ -5845,7 +5845,7 @@
         </p:nvSpPr>
         <p:spPr>
           <a:xfrm>
-            <a:off x="571500" y="1743075"/>
+            <a:off x="571500" y="1704975"/>
             <a:ext cx="3324225" cy="457200"/>
           </a:xfrm>
           <a:prstGeom prst="rect">
@@ -5884,7 +5884,7 @@
         </p:nvSpPr>
         <p:spPr>
           <a:xfrm>
-            <a:off x="571500" y="2371725"/>
+            <a:off x="571500" y="2333625"/>
             <a:ext cx="66675" cy="66675"/>
           </a:xfrm>
           <a:prstGeom prst="roundRect">
@@ -5911,7 +5911,7 @@
         </p:nvSpPr>
         <p:spPr>
           <a:xfrm>
-            <a:off x="762000" y="2238375"/>
+            <a:off x="762000" y="2200275"/>
             <a:ext cx="3133725" cy="342900"/>
           </a:xfrm>
           <a:prstGeom prst="rect">
@@ -5950,7 +5950,7 @@
         </p:nvSpPr>
         <p:spPr>
           <a:xfrm>
-            <a:off x="571500" y="2600325"/>
+            <a:off x="571500" y="2562225"/>
             <a:ext cx="66675" cy="66675"/>
           </a:xfrm>
           <a:prstGeom prst="roundRect">
@@ -5977,7 +5977,7 @@
         </p:nvSpPr>
         <p:spPr>
           <a:xfrm>
-            <a:off x="762000" y="2466975"/>
+            <a:off x="762000" y="2428875"/>
             <a:ext cx="3133725" cy="342900"/>
           </a:xfrm>
           <a:prstGeom prst="rect">
@@ -6016,7 +6016,7 @@
         </p:nvSpPr>
         <p:spPr>
           <a:xfrm>
-            <a:off x="571500" y="2828925"/>
+            <a:off x="571500" y="2790825"/>
             <a:ext cx="66675" cy="66675"/>
           </a:xfrm>
           <a:prstGeom prst="roundRect">
@@ -6043,7 +6043,7 @@
         </p:nvSpPr>
         <p:spPr>
           <a:xfrm>
-            <a:off x="762000" y="2695575"/>
+            <a:off x="762000" y="2657475"/>
             <a:ext cx="3133725" cy="342900"/>
           </a:xfrm>
           <a:prstGeom prst="rect">
@@ -6082,8 +6082,8 @@
         </p:nvSpPr>
         <p:spPr>
           <a:xfrm>
-            <a:off x="4257675" y="904875"/>
-            <a:ext cx="3667125" cy="4962525"/>
+            <a:off x="4257675" y="866775"/>
+            <a:ext cx="3667125" cy="5000625"/>
           </a:xfrm>
           <a:prstGeom prst="roundRect">
             <a:avLst>
@@ -6109,8 +6109,8 @@
         </p:nvSpPr>
         <p:spPr>
           <a:xfrm>
-            <a:off x="4257675" y="904875"/>
-            <a:ext cx="57150" cy="4962525"/>
+            <a:off x="4257675" y="866775"/>
+            <a:ext cx="57150" cy="5000625"/>
           </a:xfrm>
           <a:prstGeom prst="rect">
             <a:avLst/>
@@ -6134,7 +6134,7 @@
         </p:nvSpPr>
         <p:spPr>
           <a:xfrm>
-            <a:off x="4429125" y="1076325"/>
+            <a:off x="4429125" y="1038225"/>
             <a:ext cx="3324225" cy="171450"/>
           </a:xfrm>
           <a:prstGeom prst="rect">
@@ -6173,7 +6173,7 @@
         </p:nvSpPr>
         <p:spPr>
           <a:xfrm>
-            <a:off x="4429125" y="1323975"/>
+            <a:off x="4429125" y="1285875"/>
             <a:ext cx="3324225" cy="381000"/>
           </a:xfrm>
           <a:prstGeom prst="rect">
@@ -6212,7 +6212,7 @@
         </p:nvSpPr>
         <p:spPr>
           <a:xfrm>
-            <a:off x="4429125" y="1743075"/>
+            <a:off x="4429125" y="1704975"/>
             <a:ext cx="3324225" cy="457200"/>
           </a:xfrm>
           <a:prstGeom prst="rect">
@@ -6251,7 +6251,7 @@
         </p:nvSpPr>
         <p:spPr>
           <a:xfrm>
-            <a:off x="4429125" y="2371725"/>
+            <a:off x="4429125" y="2333625"/>
             <a:ext cx="66675" cy="66675"/>
           </a:xfrm>
           <a:prstGeom prst="roundRect">
@@ -6278,7 +6278,7 @@
         </p:nvSpPr>
         <p:spPr>
           <a:xfrm>
-            <a:off x="4619625" y="2238375"/>
+            <a:off x="4619625" y="2200275"/>
             <a:ext cx="3133725" cy="342900"/>
           </a:xfrm>
           <a:prstGeom prst="rect">
@@ -6317,7 +6317,7 @@
         </p:nvSpPr>
         <p:spPr>
           <a:xfrm>
-            <a:off x="4429125" y="2600325"/>
+            <a:off x="4429125" y="2562225"/>
             <a:ext cx="66675" cy="66675"/>
           </a:xfrm>
           <a:prstGeom prst="roundRect">
@@ -6344,7 +6344,7 @@
         </p:nvSpPr>
         <p:spPr>
           <a:xfrm>
-            <a:off x="4619625" y="2466975"/>
+            <a:off x="4619625" y="2428875"/>
             <a:ext cx="3133725" cy="342900"/>
           </a:xfrm>
           <a:prstGeom prst="rect">
@@ -6383,7 +6383,7 @@
         </p:nvSpPr>
         <p:spPr>
           <a:xfrm>
-            <a:off x="4429125" y="2828925"/>
+            <a:off x="4429125" y="2790825"/>
             <a:ext cx="66675" cy="66675"/>
           </a:xfrm>
           <a:prstGeom prst="roundRect">
@@ -6410,7 +6410,7 @@
         </p:nvSpPr>
         <p:spPr>
           <a:xfrm>
-            <a:off x="4619625" y="2695575"/>
+            <a:off x="4619625" y="2657475"/>
             <a:ext cx="3133725" cy="342900"/>
           </a:xfrm>
           <a:prstGeom prst="rect">
@@ -6449,8 +6449,8 @@
         </p:nvSpPr>
         <p:spPr>
           <a:xfrm>
-            <a:off x="8115300" y="904875"/>
-            <a:ext cx="3667125" cy="4962525"/>
+            <a:off x="8115300" y="866775"/>
+            <a:ext cx="3667125" cy="5000625"/>
           </a:xfrm>
           <a:prstGeom prst="roundRect">
             <a:avLst>
@@ -6476,8 +6476,8 @@
         </p:nvSpPr>
         <p:spPr>
           <a:xfrm>
-            <a:off x="8115300" y="904875"/>
-            <a:ext cx="57150" cy="4962525"/>
+            <a:off x="8115300" y="866775"/>
+            <a:ext cx="57150" cy="5000625"/>
           </a:xfrm>
           <a:prstGeom prst="rect">
             <a:avLst/>
@@ -6501,7 +6501,7 @@
         </p:nvSpPr>
         <p:spPr>
           <a:xfrm>
-            <a:off x="8286750" y="1076325"/>
+            <a:off x="8286750" y="1038225"/>
             <a:ext cx="3324225" cy="171450"/>
           </a:xfrm>
           <a:prstGeom prst="rect">
@@ -6540,7 +6540,7 @@
         </p:nvSpPr>
         <p:spPr>
           <a:xfrm>
-            <a:off x="8286750" y="1323975"/>
+            <a:off x="8286750" y="1285875"/>
             <a:ext cx="3324225" cy="381000"/>
           </a:xfrm>
           <a:prstGeom prst="rect">
@@ -6579,7 +6579,7 @@
         </p:nvSpPr>
         <p:spPr>
           <a:xfrm>
-            <a:off x="8286750" y="1743075"/>
+            <a:off x="8286750" y="1704975"/>
             <a:ext cx="3324225" cy="457200"/>
           </a:xfrm>
           <a:prstGeom prst="rect">
@@ -6618,7 +6618,7 @@
         </p:nvSpPr>
         <p:spPr>
           <a:xfrm>
-            <a:off x="8286750" y="2371725"/>
+            <a:off x="8286750" y="2333625"/>
             <a:ext cx="66675" cy="66675"/>
           </a:xfrm>
           <a:prstGeom prst="roundRect">
@@ -6645,7 +6645,7 @@
         </p:nvSpPr>
         <p:spPr>
           <a:xfrm>
-            <a:off x="8477250" y="2238375"/>
+            <a:off x="8477250" y="2200275"/>
             <a:ext cx="3133725" cy="342900"/>
           </a:xfrm>
           <a:prstGeom prst="rect">
@@ -6684,7 +6684,7 @@
         </p:nvSpPr>
         <p:spPr>
           <a:xfrm>
-            <a:off x="8286750" y="2600325"/>
+            <a:off x="8286750" y="2562225"/>
             <a:ext cx="66675" cy="66675"/>
           </a:xfrm>
           <a:prstGeom prst="roundRect">
@@ -6711,7 +6711,7 @@
         </p:nvSpPr>
         <p:spPr>
           <a:xfrm>
-            <a:off x="8477250" y="2466975"/>
+            <a:off x="8477250" y="2428875"/>
             <a:ext cx="3133725" cy="342900"/>
           </a:xfrm>
           <a:prstGeom prst="rect">
@@ -6750,7 +6750,7 @@
         </p:nvSpPr>
         <p:spPr>
           <a:xfrm>
-            <a:off x="8286750" y="2828925"/>
+            <a:off x="8286750" y="2790825"/>
             <a:ext cx="66675" cy="66675"/>
           </a:xfrm>
           <a:prstGeom prst="roundRect">
@@ -6777,7 +6777,7 @@
         </p:nvSpPr>
         <p:spPr>
           <a:xfrm>
-            <a:off x="8477250" y="2695575"/>
+            <a:off x="8477250" y="2657475"/>
             <a:ext cx="3133725" cy="342900"/>
           </a:xfrm>
           <a:prstGeom prst="rect">
@@ -7073,7 +7073,7 @@
         </p:nvSpPr>
         <p:spPr>
           <a:xfrm>
-            <a:off x="1905000" y="1457325"/>
+            <a:off x="1905000" y="1419225"/>
             <a:ext cx="3168650" cy="171450"/>
           </a:xfrm>
           <a:prstGeom prst="rect">
@@ -7112,7 +7112,7 @@
         </p:nvSpPr>
         <p:spPr>
           <a:xfrm>
-            <a:off x="5226050" y="1457325"/>
+            <a:off x="5226050" y="1419225"/>
             <a:ext cx="3168650" cy="171450"/>
           </a:xfrm>
           <a:prstGeom prst="rect">
@@ -7151,7 +7151,7 @@
         </p:nvSpPr>
         <p:spPr>
           <a:xfrm>
-            <a:off x="8547100" y="1457325"/>
+            <a:off x="8547100" y="1419225"/>
             <a:ext cx="3168650" cy="171450"/>
           </a:xfrm>
           <a:prstGeom prst="rect">
@@ -7190,8 +7190,8 @@
         </p:nvSpPr>
         <p:spPr>
           <a:xfrm>
-            <a:off x="400050" y="1800225"/>
-            <a:ext cx="1257300" cy="828675"/>
+            <a:off x="400050" y="1762125"/>
+            <a:ext cx="1257300" cy="836295"/>
           </a:xfrm>
           <a:prstGeom prst="rect">
             <a:avLst/>
@@ -7229,8 +7229,8 @@
         </p:nvSpPr>
         <p:spPr>
           <a:xfrm>
-            <a:off x="1828800" y="1800225"/>
-            <a:ext cx="9963150" cy="828675"/>
+            <a:off x="1828800" y="1762125"/>
+            <a:ext cx="9963150" cy="836295"/>
           </a:xfrm>
           <a:prstGeom prst="rect">
             <a:avLst/>
@@ -7254,8 +7254,8 @@
         </p:nvSpPr>
         <p:spPr>
           <a:xfrm>
-            <a:off x="400050" y="2705100"/>
-            <a:ext cx="1257300" cy="828675"/>
+            <a:off x="400050" y="2674620"/>
+            <a:ext cx="1257300" cy="836295"/>
           </a:xfrm>
           <a:prstGeom prst="rect">
             <a:avLst/>
@@ -7293,8 +7293,8 @@
         </p:nvSpPr>
         <p:spPr>
           <a:xfrm>
-            <a:off x="1828800" y="2705100"/>
-            <a:ext cx="9963150" cy="828675"/>
+            <a:off x="1828800" y="2674620"/>
+            <a:ext cx="9963150" cy="836295"/>
           </a:xfrm>
           <a:prstGeom prst="rect">
             <a:avLst/>
@@ -7318,8 +7318,8 @@
         </p:nvSpPr>
         <p:spPr>
           <a:xfrm>
-            <a:off x="400050" y="3609975"/>
-            <a:ext cx="1257300" cy="828675"/>
+            <a:off x="400050" y="3587115"/>
+            <a:ext cx="1257300" cy="836295"/>
           </a:xfrm>
           <a:prstGeom prst="rect">
             <a:avLst/>
@@ -7357,8 +7357,8 @@
         </p:nvSpPr>
         <p:spPr>
           <a:xfrm>
-            <a:off x="1828800" y="3609975"/>
-            <a:ext cx="9963150" cy="828675"/>
+            <a:off x="1828800" y="3587115"/>
+            <a:ext cx="9963150" cy="836295"/>
           </a:xfrm>
           <a:prstGeom prst="rect">
             <a:avLst/>
@@ -7382,8 +7382,8 @@
         </p:nvSpPr>
         <p:spPr>
           <a:xfrm>
-            <a:off x="400050" y="4514850"/>
-            <a:ext cx="1257300" cy="828675"/>
+            <a:off x="400050" y="4499610"/>
+            <a:ext cx="1257300" cy="836295"/>
           </a:xfrm>
           <a:prstGeom prst="rect">
             <a:avLst/>
@@ -7421,8 +7421,8 @@
         </p:nvSpPr>
         <p:spPr>
           <a:xfrm>
-            <a:off x="1828800" y="4514850"/>
-            <a:ext cx="9963150" cy="828675"/>
+            <a:off x="1828800" y="4499610"/>
+            <a:ext cx="9963150" cy="836295"/>
           </a:xfrm>
           <a:prstGeom prst="rect">
             <a:avLst/>
@@ -7446,8 +7446,8 @@
         </p:nvSpPr>
         <p:spPr>
           <a:xfrm>
-            <a:off x="400050" y="5419725"/>
-            <a:ext cx="1257300" cy="828675"/>
+            <a:off x="400050" y="5412105"/>
+            <a:ext cx="1257300" cy="836295"/>
           </a:xfrm>
           <a:prstGeom prst="rect">
             <a:avLst/>
@@ -7485,8 +7485,8 @@
         </p:nvSpPr>
         <p:spPr>
           <a:xfrm>
-            <a:off x="1828800" y="5419725"/>
-            <a:ext cx="9963150" cy="828675"/>
+            <a:off x="1828800" y="5412105"/>
+            <a:ext cx="9963150" cy="836295"/>
           </a:xfrm>
           <a:prstGeom prst="rect">
             <a:avLst/>
@@ -7510,7 +7510,7 @@
         </p:nvSpPr>
         <p:spPr>
           <a:xfrm>
-            <a:off x="1924050" y="2024062"/>
+            <a:off x="1924050" y="1989773"/>
             <a:ext cx="3130550" cy="381000"/>
           </a:xfrm>
           <a:prstGeom prst="roundRect">
@@ -7537,7 +7537,7 @@
         </p:nvSpPr>
         <p:spPr>
           <a:xfrm>
-            <a:off x="2000250" y="2024062"/>
+            <a:off x="2000250" y="1989773"/>
             <a:ext cx="2978150" cy="381000"/>
           </a:xfrm>
           <a:prstGeom prst="rect">
@@ -7576,7 +7576,7 @@
         </p:nvSpPr>
         <p:spPr>
           <a:xfrm>
-            <a:off x="1924050" y="2928938"/>
+            <a:off x="1924050" y="2902268"/>
             <a:ext cx="3130550" cy="381000"/>
           </a:xfrm>
           <a:prstGeom prst="roundRect">
@@ -7603,7 +7603,7 @@
         </p:nvSpPr>
         <p:spPr>
           <a:xfrm>
-            <a:off x="2000250" y="2928938"/>
+            <a:off x="2000250" y="2902268"/>
             <a:ext cx="2978150" cy="381000"/>
           </a:xfrm>
           <a:prstGeom prst="rect">
@@ -7642,7 +7642,7 @@
         </p:nvSpPr>
         <p:spPr>
           <a:xfrm>
-            <a:off x="5245100" y="3833812"/>
+            <a:off x="5245100" y="3814763"/>
             <a:ext cx="3130550" cy="381000"/>
           </a:xfrm>
           <a:prstGeom prst="roundRect">
@@ -7669,7 +7669,7 @@
         </p:nvSpPr>
         <p:spPr>
           <a:xfrm>
-            <a:off x="5321300" y="3833812"/>
+            <a:off x="5321300" y="3814763"/>
             <a:ext cx="2978150" cy="381000"/>
           </a:xfrm>
           <a:prstGeom prst="rect">
@@ -7708,7 +7708,7 @@
         </p:nvSpPr>
         <p:spPr>
           <a:xfrm>
-            <a:off x="5245100" y="4738688"/>
+            <a:off x="5245100" y="4727257"/>
             <a:ext cx="3130550" cy="381000"/>
           </a:xfrm>
           <a:prstGeom prst="roundRect">
@@ -7735,7 +7735,7 @@
         </p:nvSpPr>
         <p:spPr>
           <a:xfrm>
-            <a:off x="5321300" y="4738688"/>
+            <a:off x="5321300" y="4727257"/>
             <a:ext cx="2978150" cy="381000"/>
           </a:xfrm>
           <a:prstGeom prst="rect">
@@ -7774,7 +7774,7 @@
         </p:nvSpPr>
         <p:spPr>
           <a:xfrm>
-            <a:off x="8566150" y="5643563"/>
+            <a:off x="8566150" y="5639753"/>
             <a:ext cx="3130550" cy="381000"/>
           </a:xfrm>
           <a:prstGeom prst="roundRect">
@@ -7801,7 +7801,7 @@
         </p:nvSpPr>
         <p:spPr>
           <a:xfrm>
-            <a:off x="8642350" y="5643563"/>
+            <a:off x="8642350" y="5639753"/>
             <a:ext cx="2978150" cy="381000"/>
           </a:xfrm>
           <a:prstGeom prst="rect">

</xml_diff>